<commit_message>
Update/Make layout script fully cross-platform and remove pywin32
</commit_message>
<xml_diff>
--- a/example/example.pptx
+++ b/example/example.pptx
@@ -1,6 +1,6 @@
 
 <file path=ppt/presentation.xml><?xml version="1.0" encoding="utf-8"?>
-<p:presentation xmlns:a="http://schemas.openxmlformats.org/drawingml/2006/main" xmlns:r="http://schemas.openxmlformats.org/officeDocument/2006/relationships" xmlns:p="http://schemas.openxmlformats.org/presentationml/2006/main" saveSubsetFonts="1" autoCompressPictures="0">
+<p:presentation xmlns:a="http://schemas.openxmlformats.org/drawingml/2006/main" xmlns:p="http://schemas.openxmlformats.org/presentationml/2006/main" xmlns:r="http://schemas.openxmlformats.org/officeDocument/2006/relationships" autoCompressPictures="0" saveSubsetFonts="1">
   <p:sldMasterIdLst>
     <p:sldMasterId id="2147483648" r:id="rId1"/>
   </p:sldMasterIdLst>
@@ -31,8 +31,8 @@
     <a:defPPr>
       <a:defRPr lang="en-US"/>
     </a:defPPr>
-    <a:lvl1pPr marL="0" algn="l" defTabSz="457200" rtl="0" eaLnBrk="1" latinLnBrk="0" hangingPunct="1">
-      <a:defRPr sz="1800" kern="1200">
+    <a:lvl1pPr algn="l" defTabSz="457200" eaLnBrk="1" hangingPunct="1" latinLnBrk="0" marL="0" rtl="0">
+      <a:defRPr kern="1200" sz="1800">
         <a:solidFill>
           <a:schemeClr val="tx1"/>
         </a:solidFill>
@@ -41,8 +41,8 @@
         <a:cs typeface="+mn-cs"/>
       </a:defRPr>
     </a:lvl1pPr>
-    <a:lvl2pPr marL="457200" algn="l" defTabSz="457200" rtl="0" eaLnBrk="1" latinLnBrk="0" hangingPunct="1">
-      <a:defRPr sz="1800" kern="1200">
+    <a:lvl2pPr algn="l" defTabSz="457200" eaLnBrk="1" hangingPunct="1" latinLnBrk="0" marL="457200" rtl="0">
+      <a:defRPr kern="1200" sz="1800">
         <a:solidFill>
           <a:schemeClr val="tx1"/>
         </a:solidFill>
@@ -51,8 +51,8 @@
         <a:cs typeface="+mn-cs"/>
       </a:defRPr>
     </a:lvl2pPr>
-    <a:lvl3pPr marL="914400" algn="l" defTabSz="457200" rtl="0" eaLnBrk="1" latinLnBrk="0" hangingPunct="1">
-      <a:defRPr sz="1800" kern="1200">
+    <a:lvl3pPr algn="l" defTabSz="457200" eaLnBrk="1" hangingPunct="1" latinLnBrk="0" marL="914400" rtl="0">
+      <a:defRPr kern="1200" sz="1800">
         <a:solidFill>
           <a:schemeClr val="tx1"/>
         </a:solidFill>
@@ -61,8 +61,8 @@
         <a:cs typeface="+mn-cs"/>
       </a:defRPr>
     </a:lvl3pPr>
-    <a:lvl4pPr marL="1371600" algn="l" defTabSz="457200" rtl="0" eaLnBrk="1" latinLnBrk="0" hangingPunct="1">
-      <a:defRPr sz="1800" kern="1200">
+    <a:lvl4pPr algn="l" defTabSz="457200" eaLnBrk="1" hangingPunct="1" latinLnBrk="0" marL="1371600" rtl="0">
+      <a:defRPr kern="1200" sz="1800">
         <a:solidFill>
           <a:schemeClr val="tx1"/>
         </a:solidFill>
@@ -71,8 +71,8 @@
         <a:cs typeface="+mn-cs"/>
       </a:defRPr>
     </a:lvl4pPr>
-    <a:lvl5pPr marL="1828800" algn="l" defTabSz="457200" rtl="0" eaLnBrk="1" latinLnBrk="0" hangingPunct="1">
-      <a:defRPr sz="1800" kern="1200">
+    <a:lvl5pPr algn="l" defTabSz="457200" eaLnBrk="1" hangingPunct="1" latinLnBrk="0" marL="1828800" rtl="0">
+      <a:defRPr kern="1200" sz="1800">
         <a:solidFill>
           <a:schemeClr val="tx1"/>
         </a:solidFill>
@@ -81,8 +81,8 @@
         <a:cs typeface="+mn-cs"/>
       </a:defRPr>
     </a:lvl5pPr>
-    <a:lvl6pPr marL="2286000" algn="l" defTabSz="457200" rtl="0" eaLnBrk="1" latinLnBrk="0" hangingPunct="1">
-      <a:defRPr sz="1800" kern="1200">
+    <a:lvl6pPr algn="l" defTabSz="457200" eaLnBrk="1" hangingPunct="1" latinLnBrk="0" marL="2286000" rtl="0">
+      <a:defRPr kern="1200" sz="1800">
         <a:solidFill>
           <a:schemeClr val="tx1"/>
         </a:solidFill>
@@ -91,8 +91,8 @@
         <a:cs typeface="+mn-cs"/>
       </a:defRPr>
     </a:lvl6pPr>
-    <a:lvl7pPr marL="2743200" algn="l" defTabSz="457200" rtl="0" eaLnBrk="1" latinLnBrk="0" hangingPunct="1">
-      <a:defRPr sz="1800" kern="1200">
+    <a:lvl7pPr algn="l" defTabSz="457200" eaLnBrk="1" hangingPunct="1" latinLnBrk="0" marL="2743200" rtl="0">
+      <a:defRPr kern="1200" sz="1800">
         <a:solidFill>
           <a:schemeClr val="tx1"/>
         </a:solidFill>
@@ -101,8 +101,8 @@
         <a:cs typeface="+mn-cs"/>
       </a:defRPr>
     </a:lvl7pPr>
-    <a:lvl8pPr marL="3200400" algn="l" defTabSz="457200" rtl="0" eaLnBrk="1" latinLnBrk="0" hangingPunct="1">
-      <a:defRPr sz="1800" kern="1200">
+    <a:lvl8pPr algn="l" defTabSz="457200" eaLnBrk="1" hangingPunct="1" latinLnBrk="0" marL="3200400" rtl="0">
+      <a:defRPr kern="1200" sz="1800">
         <a:solidFill>
           <a:schemeClr val="tx1"/>
         </a:solidFill>
@@ -111,8 +111,8 @@
         <a:cs typeface="+mn-cs"/>
       </a:defRPr>
     </a:lvl8pPr>
-    <a:lvl9pPr marL="3657600" algn="l" defTabSz="457200" rtl="0" eaLnBrk="1" latinLnBrk="0" hangingPunct="1">
-      <a:defRPr sz="1800" kern="1200">
+    <a:lvl9pPr algn="l" defTabSz="457200" eaLnBrk="1" hangingPunct="1" latinLnBrk="0" marL="3657600" rtl="0">
+      <a:defRPr kern="1200" sz="1800">
         <a:solidFill>
           <a:schemeClr val="tx1"/>
         </a:solidFill>
@@ -491,7 +491,7 @@
 </file>
 
 <file path=ppt/notesSlides/notesSlide1.xml><?xml version="1.0" encoding="utf-8"?>
-<p:notes xmlns:a="http://schemas.openxmlformats.org/drawingml/2006/main" xmlns:r="http://schemas.openxmlformats.org/officeDocument/2006/relationships" xmlns:p="http://schemas.openxmlformats.org/presentationml/2006/main">
+<p:notes xmlns:a="http://schemas.openxmlformats.org/drawingml/2006/main" xmlns:p="http://schemas.openxmlformats.org/presentationml/2006/main">
   <p:cSld>
     <p:spTree>
       <p:nvGrpSpPr>
@@ -534,7 +534,13 @@
           <a:bodyPr/>
           <a:lstStyle/>
           <a:p>
-            <a:endParaRPr lang="de-DE"/>
+            <a:pPr lvl="0" indent="0" marL="0">
+              <a:buNone/>
+            </a:pPr>
+            <a:r>
+              <a:rPr/>
+              <a:t/>
+            </a:r>
           </a:p>
         </p:txBody>
       </p:sp>
@@ -545,7 +551,7 @@
             <a:spLocks noGrp="1"/>
           </p:cNvSpPr>
           <p:nvPr>
-            <p:ph type="sldNum" sz="quarter" idx="5"/>
+            <p:ph type="sldNum" sz="quarter" idx="10"/>
           </p:nvPr>
         </p:nvSpPr>
         <p:spPr/>
@@ -554,28 +560,20 @@
           <a:lstStyle/>
           <a:p>
             <a:fld id="{18BDFEC3-8487-43E8-A154-7C12CBC1FFF2}" type="slidenum">
-              <a:rPr lang="en-US" smtClean="0"/>
-              <a:t>1</a:t>
+              <a:rPr lang="en-US"/>
+              <a:t>3</a:t>
             </a:fld>
             <a:endParaRPr lang="en-US"/>
           </a:p>
         </p:txBody>
       </p:sp>
     </p:spTree>
-    <p:extLst>
-      <p:ext uri="{BB962C8B-B14F-4D97-AF65-F5344CB8AC3E}">
-        <p14:creationId xmlns:p14="http://schemas.microsoft.com/office/powerpoint/2010/main" val="2989445026"/>
-      </p:ext>
-    </p:extLst>
   </p:cSld>
-  <p:clrMapOvr>
-    <a:masterClrMapping/>
-  </p:clrMapOvr>
 </p:notes>
 </file>
 
 <file path=ppt/notesSlides/notesSlide10.xml><?xml version="1.0" encoding="utf-8"?>
-<p:notes xmlns:a="http://schemas.openxmlformats.org/drawingml/2006/main" xmlns:r="http://schemas.openxmlformats.org/officeDocument/2006/relationships" xmlns:p="http://schemas.openxmlformats.org/presentationml/2006/main">
+<p:notes xmlns:a="http://schemas.openxmlformats.org/drawingml/2006/main" xmlns:p="http://schemas.openxmlformats.org/presentationml/2006/main">
   <p:cSld>
     <p:spTree>
       <p:nvGrpSpPr>
@@ -618,10 +616,13 @@
           <a:bodyPr/>
           <a:lstStyle/>
           <a:p>
-            <a:pPr marL="0" lvl="0" indent="0">
+            <a:pPr lvl="0" indent="0" marL="0">
               <a:buNone/>
             </a:pPr>
-            <a:endParaRPr/>
+            <a:r>
+              <a:rPr/>
+              <a:t/>
+            </a:r>
           </a:p>
         </p:txBody>
       </p:sp>
@@ -642,7 +643,7 @@
           <a:p>
             <a:fld id="{18BDFEC3-8487-43E8-A154-7C12CBC1FFF2}" type="slidenum">
               <a:rPr lang="en-US"/>
-              <a:t>10</a:t>
+              <a:t>16</a:t>
             </a:fld>
             <a:endParaRPr lang="en-US"/>
           </a:p>
@@ -650,14 +651,11 @@
       </p:sp>
     </p:spTree>
   </p:cSld>
-  <p:clrMapOvr>
-    <a:masterClrMapping/>
-  </p:clrMapOvr>
 </p:notes>
 </file>
 
-<file path=ppt/notesSlides/notesSlide11.xml><?xml version="1.0" encoding="utf-8"?>
-<p:notes xmlns:a="http://schemas.openxmlformats.org/drawingml/2006/main" xmlns:r="http://schemas.openxmlformats.org/officeDocument/2006/relationships" xmlns:p="http://schemas.openxmlformats.org/presentationml/2006/main">
+<file path=ppt/notesSlides/notesSlide2.xml><?xml version="1.0" encoding="utf-8"?>
+<p:notes xmlns:a="http://schemas.openxmlformats.org/drawingml/2006/main" xmlns:p="http://schemas.openxmlformats.org/presentationml/2006/main">
   <p:cSld>
     <p:spTree>
       <p:nvGrpSpPr>
@@ -700,7 +698,13 @@
           <a:bodyPr/>
           <a:lstStyle/>
           <a:p>
-            <a:endParaRPr lang="de-DE"/>
+            <a:pPr lvl="0" indent="0" marL="0">
+              <a:buNone/>
+            </a:pPr>
+            <a:r>
+              <a:rPr/>
+              <a:t/>
+            </a:r>
           </a:p>
         </p:txBody>
       </p:sp>
@@ -711,7 +715,7 @@
             <a:spLocks noGrp="1"/>
           </p:cNvSpPr>
           <p:nvPr>
-            <p:ph type="sldNum" sz="quarter" idx="5"/>
+            <p:ph type="sldNum" sz="quarter" idx="10"/>
           </p:nvPr>
         </p:nvSpPr>
         <p:spPr/>
@@ -720,28 +724,20 @@
           <a:lstStyle/>
           <a:p>
             <a:fld id="{18BDFEC3-8487-43E8-A154-7C12CBC1FFF2}" type="slidenum">
-              <a:rPr lang="en-US" smtClean="0"/>
-              <a:t>11</a:t>
+              <a:rPr lang="en-US"/>
+              <a:t>4</a:t>
             </a:fld>
             <a:endParaRPr lang="en-US"/>
           </a:p>
         </p:txBody>
       </p:sp>
     </p:spTree>
-    <p:extLst>
-      <p:ext uri="{BB962C8B-B14F-4D97-AF65-F5344CB8AC3E}">
-        <p14:creationId xmlns:p14="http://schemas.microsoft.com/office/powerpoint/2010/main" val="3301485963"/>
-      </p:ext>
-    </p:extLst>
   </p:cSld>
-  <p:clrMapOvr>
-    <a:masterClrMapping/>
-  </p:clrMapOvr>
 </p:notes>
 </file>
 
-<file path=ppt/notesSlides/notesSlide12.xml><?xml version="1.0" encoding="utf-8"?>
-<p:notes xmlns:a="http://schemas.openxmlformats.org/drawingml/2006/main" xmlns:r="http://schemas.openxmlformats.org/officeDocument/2006/relationships" xmlns:p="http://schemas.openxmlformats.org/presentationml/2006/main">
+<file path=ppt/notesSlides/notesSlide3.xml><?xml version="1.0" encoding="utf-8"?>
+<p:notes xmlns:a="http://schemas.openxmlformats.org/drawingml/2006/main" xmlns:p="http://schemas.openxmlformats.org/presentationml/2006/main">
   <p:cSld>
     <p:spTree>
       <p:nvGrpSpPr>
@@ -784,10 +780,13 @@
           <a:bodyPr/>
           <a:lstStyle/>
           <a:p>
-            <a:pPr marL="0" lvl="0" indent="0">
+            <a:pPr lvl="0" indent="0" marL="0">
               <a:buNone/>
             </a:pPr>
-            <a:endParaRPr/>
+            <a:r>
+              <a:rPr/>
+              <a:t/>
+            </a:r>
           </a:p>
         </p:txBody>
       </p:sp>
@@ -808,7 +807,7 @@
           <a:p>
             <a:fld id="{18BDFEC3-8487-43E8-A154-7C12CBC1FFF2}" type="slidenum">
               <a:rPr lang="en-US"/>
-              <a:t>12</a:t>
+              <a:t>6</a:t>
             </a:fld>
             <a:endParaRPr lang="en-US"/>
           </a:p>
@@ -816,14 +815,11 @@
       </p:sp>
     </p:spTree>
   </p:cSld>
-  <p:clrMapOvr>
-    <a:masterClrMapping/>
-  </p:clrMapOvr>
 </p:notes>
 </file>
 
-<file path=ppt/notesSlides/notesSlide13.xml><?xml version="1.0" encoding="utf-8"?>
-<p:notes xmlns:a="http://schemas.openxmlformats.org/drawingml/2006/main" xmlns:r="http://schemas.openxmlformats.org/officeDocument/2006/relationships" xmlns:p="http://schemas.openxmlformats.org/presentationml/2006/main">
+<file path=ppt/notesSlides/notesSlide4.xml><?xml version="1.0" encoding="utf-8"?>
+<p:notes xmlns:a="http://schemas.openxmlformats.org/drawingml/2006/main" xmlns:p="http://schemas.openxmlformats.org/presentationml/2006/main">
   <p:cSld>
     <p:spTree>
       <p:nvGrpSpPr>
@@ -866,10 +862,13 @@
           <a:bodyPr/>
           <a:lstStyle/>
           <a:p>
-            <a:pPr marL="0" lvl="0" indent="0">
+            <a:pPr lvl="0" indent="0" marL="0">
               <a:buNone/>
             </a:pPr>
-            <a:endParaRPr/>
+            <a:r>
+              <a:rPr/>
+              <a:t/>
+            </a:r>
           </a:p>
         </p:txBody>
       </p:sp>
@@ -890,7 +889,7 @@
           <a:p>
             <a:fld id="{18BDFEC3-8487-43E8-A154-7C12CBC1FFF2}" type="slidenum">
               <a:rPr lang="en-US"/>
-              <a:t>13</a:t>
+              <a:t>7</a:t>
             </a:fld>
             <a:endParaRPr lang="en-US"/>
           </a:p>
@@ -898,14 +897,11 @@
       </p:sp>
     </p:spTree>
   </p:cSld>
-  <p:clrMapOvr>
-    <a:masterClrMapping/>
-  </p:clrMapOvr>
 </p:notes>
 </file>
 
-<file path=ppt/notesSlides/notesSlide14.xml><?xml version="1.0" encoding="utf-8"?>
-<p:notes xmlns:a="http://schemas.openxmlformats.org/drawingml/2006/main" xmlns:r="http://schemas.openxmlformats.org/officeDocument/2006/relationships" xmlns:p="http://schemas.openxmlformats.org/presentationml/2006/main">
+<file path=ppt/notesSlides/notesSlide5.xml><?xml version="1.0" encoding="utf-8"?>
+<p:notes xmlns:a="http://schemas.openxmlformats.org/drawingml/2006/main" xmlns:p="http://schemas.openxmlformats.org/presentationml/2006/main">
   <p:cSld>
     <p:spTree>
       <p:nvGrpSpPr>
@@ -948,7 +944,13 @@
           <a:bodyPr/>
           <a:lstStyle/>
           <a:p>
-            <a:endParaRPr lang="de-DE"/>
+            <a:pPr lvl="0" indent="0" marL="0">
+              <a:buNone/>
+            </a:pPr>
+            <a:r>
+              <a:rPr/>
+              <a:t/>
+            </a:r>
           </a:p>
         </p:txBody>
       </p:sp>
@@ -959,7 +961,7 @@
             <a:spLocks noGrp="1"/>
           </p:cNvSpPr>
           <p:nvPr>
-            <p:ph type="sldNum" sz="quarter" idx="5"/>
+            <p:ph type="sldNum" sz="quarter" idx="10"/>
           </p:nvPr>
         </p:nvSpPr>
         <p:spPr/>
@@ -968,28 +970,20 @@
           <a:lstStyle/>
           <a:p>
             <a:fld id="{18BDFEC3-8487-43E8-A154-7C12CBC1FFF2}" type="slidenum">
-              <a:rPr lang="en-US" smtClean="0"/>
-              <a:t>14</a:t>
+              <a:rPr lang="en-US"/>
+              <a:t>9</a:t>
             </a:fld>
             <a:endParaRPr lang="en-US"/>
           </a:p>
         </p:txBody>
       </p:sp>
     </p:spTree>
-    <p:extLst>
-      <p:ext uri="{BB962C8B-B14F-4D97-AF65-F5344CB8AC3E}">
-        <p14:creationId xmlns:p14="http://schemas.microsoft.com/office/powerpoint/2010/main" val="2266585854"/>
-      </p:ext>
-    </p:extLst>
   </p:cSld>
-  <p:clrMapOvr>
-    <a:masterClrMapping/>
-  </p:clrMapOvr>
 </p:notes>
 </file>
 
-<file path=ppt/notesSlides/notesSlide15.xml><?xml version="1.0" encoding="utf-8"?>
-<p:notes xmlns:a="http://schemas.openxmlformats.org/drawingml/2006/main" xmlns:r="http://schemas.openxmlformats.org/officeDocument/2006/relationships" xmlns:p="http://schemas.openxmlformats.org/presentationml/2006/main">
+<file path=ppt/notesSlides/notesSlide6.xml><?xml version="1.0" encoding="utf-8"?>
+<p:notes xmlns:a="http://schemas.openxmlformats.org/drawingml/2006/main" xmlns:p="http://schemas.openxmlformats.org/presentationml/2006/main">
   <p:cSld>
     <p:spTree>
       <p:nvGrpSpPr>
@@ -1032,10 +1026,13 @@
           <a:bodyPr/>
           <a:lstStyle/>
           <a:p>
-            <a:pPr marL="0" lvl="0" indent="0">
+            <a:pPr lvl="0" indent="0" marL="0">
               <a:buNone/>
             </a:pPr>
-            <a:endParaRPr/>
+            <a:r>
+              <a:rPr/>
+              <a:t/>
+            </a:r>
           </a:p>
         </p:txBody>
       </p:sp>
@@ -1056,7 +1053,7 @@
           <a:p>
             <a:fld id="{18BDFEC3-8487-43E8-A154-7C12CBC1FFF2}" type="slidenum">
               <a:rPr lang="en-US"/>
-              <a:t>15</a:t>
+              <a:t>10</a:t>
             </a:fld>
             <a:endParaRPr lang="en-US"/>
           </a:p>
@@ -1064,14 +1061,11 @@
       </p:sp>
     </p:spTree>
   </p:cSld>
-  <p:clrMapOvr>
-    <a:masterClrMapping/>
-  </p:clrMapOvr>
 </p:notes>
 </file>
 
-<file path=ppt/notesSlides/notesSlide16.xml><?xml version="1.0" encoding="utf-8"?>
-<p:notes xmlns:a="http://schemas.openxmlformats.org/drawingml/2006/main" xmlns:r="http://schemas.openxmlformats.org/officeDocument/2006/relationships" xmlns:p="http://schemas.openxmlformats.org/presentationml/2006/main">
+<file path=ppt/notesSlides/notesSlide7.xml><?xml version="1.0" encoding="utf-8"?>
+<p:notes xmlns:a="http://schemas.openxmlformats.org/drawingml/2006/main" xmlns:p="http://schemas.openxmlformats.org/presentationml/2006/main">
   <p:cSld>
     <p:spTree>
       <p:nvGrpSpPr>
@@ -1114,10 +1108,13 @@
           <a:bodyPr/>
           <a:lstStyle/>
           <a:p>
-            <a:pPr marL="0" lvl="0" indent="0">
+            <a:pPr lvl="0" indent="0" marL="0">
               <a:buNone/>
             </a:pPr>
-            <a:endParaRPr/>
+            <a:r>
+              <a:rPr/>
+              <a:t/>
+            </a:r>
           </a:p>
         </p:txBody>
       </p:sp>
@@ -1138,7 +1135,7 @@
           <a:p>
             <a:fld id="{18BDFEC3-8487-43E8-A154-7C12CBC1FFF2}" type="slidenum">
               <a:rPr lang="en-US"/>
-              <a:t>16</a:t>
+              <a:t>12</a:t>
             </a:fld>
             <a:endParaRPr lang="en-US"/>
           </a:p>
@@ -1146,14 +1143,11 @@
       </p:sp>
     </p:spTree>
   </p:cSld>
-  <p:clrMapOvr>
-    <a:masterClrMapping/>
-  </p:clrMapOvr>
 </p:notes>
 </file>
 
-<file path=ppt/notesSlides/notesSlide2.xml><?xml version="1.0" encoding="utf-8"?>
-<p:notes xmlns:a="http://schemas.openxmlformats.org/drawingml/2006/main" xmlns:r="http://schemas.openxmlformats.org/officeDocument/2006/relationships" xmlns:p="http://schemas.openxmlformats.org/presentationml/2006/main">
+<file path=ppt/notesSlides/notesSlide8.xml><?xml version="1.0" encoding="utf-8"?>
+<p:notes xmlns:a="http://schemas.openxmlformats.org/drawingml/2006/main" xmlns:p="http://schemas.openxmlformats.org/presentationml/2006/main">
   <p:cSld>
     <p:spTree>
       <p:nvGrpSpPr>
@@ -1196,7 +1190,13 @@
           <a:bodyPr/>
           <a:lstStyle/>
           <a:p>
-            <a:endParaRPr lang="de-DE"/>
+            <a:pPr lvl="0" indent="0" marL="0">
+              <a:buNone/>
+            </a:pPr>
+            <a:r>
+              <a:rPr/>
+              <a:t/>
+            </a:r>
           </a:p>
         </p:txBody>
       </p:sp>
@@ -1207,7 +1207,7 @@
             <a:spLocks noGrp="1"/>
           </p:cNvSpPr>
           <p:nvPr>
-            <p:ph type="sldNum" sz="quarter" idx="5"/>
+            <p:ph type="sldNum" sz="quarter" idx="10"/>
           </p:nvPr>
         </p:nvSpPr>
         <p:spPr/>
@@ -1216,28 +1216,20 @@
           <a:lstStyle/>
           <a:p>
             <a:fld id="{18BDFEC3-8487-43E8-A154-7C12CBC1FFF2}" type="slidenum">
-              <a:rPr lang="en-US" smtClean="0"/>
-              <a:t>2</a:t>
+              <a:rPr lang="en-US"/>
+              <a:t>13</a:t>
             </a:fld>
             <a:endParaRPr lang="en-US"/>
           </a:p>
         </p:txBody>
       </p:sp>
     </p:spTree>
-    <p:extLst>
-      <p:ext uri="{BB962C8B-B14F-4D97-AF65-F5344CB8AC3E}">
-        <p14:creationId xmlns:p14="http://schemas.microsoft.com/office/powerpoint/2010/main" val="1920274222"/>
-      </p:ext>
-    </p:extLst>
   </p:cSld>
-  <p:clrMapOvr>
-    <a:masterClrMapping/>
-  </p:clrMapOvr>
 </p:notes>
 </file>
 
-<file path=ppt/notesSlides/notesSlide3.xml><?xml version="1.0" encoding="utf-8"?>
-<p:notes xmlns:a="http://schemas.openxmlformats.org/drawingml/2006/main" xmlns:r="http://schemas.openxmlformats.org/officeDocument/2006/relationships" xmlns:p="http://schemas.openxmlformats.org/presentationml/2006/main">
+<file path=ppt/notesSlides/notesSlide9.xml><?xml version="1.0" encoding="utf-8"?>
+<p:notes xmlns:a="http://schemas.openxmlformats.org/drawingml/2006/main" xmlns:p="http://schemas.openxmlformats.org/presentationml/2006/main">
   <p:cSld>
     <p:spTree>
       <p:nvGrpSpPr>
@@ -1280,10 +1272,13 @@
           <a:bodyPr/>
           <a:lstStyle/>
           <a:p>
-            <a:pPr marL="0" lvl="0" indent="0">
+            <a:pPr lvl="0" indent="0" marL="0">
               <a:buNone/>
             </a:pPr>
-            <a:endParaRPr/>
+            <a:r>
+              <a:rPr/>
+              <a:t/>
+            </a:r>
           </a:p>
         </p:txBody>
       </p:sp>
@@ -1304,7 +1299,7 @@
           <a:p>
             <a:fld id="{18BDFEC3-8487-43E8-A154-7C12CBC1FFF2}" type="slidenum">
               <a:rPr lang="en-US"/>
-              <a:t>3</a:t>
+              <a:t>15</a:t>
             </a:fld>
             <a:endParaRPr lang="en-US"/>
           </a:p>
@@ -1312,505 +1307,6 @@
       </p:sp>
     </p:spTree>
   </p:cSld>
-  <p:clrMapOvr>
-    <a:masterClrMapping/>
-  </p:clrMapOvr>
-</p:notes>
-</file>
-
-<file path=ppt/notesSlides/notesSlide4.xml><?xml version="1.0" encoding="utf-8"?>
-<p:notes xmlns:a="http://schemas.openxmlformats.org/drawingml/2006/main" xmlns:r="http://schemas.openxmlformats.org/officeDocument/2006/relationships" xmlns:p="http://schemas.openxmlformats.org/presentationml/2006/main">
-  <p:cSld>
-    <p:spTree>
-      <p:nvGrpSpPr>
-        <p:cNvPr id="1" name=""/>
-        <p:cNvGrpSpPr/>
-        <p:nvPr/>
-      </p:nvGrpSpPr>
-      <p:grpSpPr>
-        <a:xfrm>
-          <a:off x="0" y="0"/>
-          <a:ext cx="0" cy="0"/>
-          <a:chOff x="0" y="0"/>
-          <a:chExt cx="0" cy="0"/>
-        </a:xfrm>
-      </p:grpSpPr>
-      <p:sp>
-        <p:nvSpPr>
-          <p:cNvPr id="2" name="Slide Image Placeholder 1"/>
-          <p:cNvSpPr>
-            <a:spLocks noGrp="1" noRot="1" noChangeAspect="1"/>
-          </p:cNvSpPr>
-          <p:nvPr>
-            <p:ph type="sldImg"/>
-          </p:nvPr>
-        </p:nvSpPr>
-        <p:spPr/>
-      </p:sp>
-      <p:sp>
-        <p:nvSpPr>
-          <p:cNvPr id="3" name="Notes Placeholder 2"/>
-          <p:cNvSpPr>
-            <a:spLocks noGrp="1"/>
-          </p:cNvSpPr>
-          <p:nvPr>
-            <p:ph type="body" idx="1"/>
-          </p:nvPr>
-        </p:nvSpPr>
-        <p:spPr/>
-        <p:txBody>
-          <a:bodyPr/>
-          <a:lstStyle/>
-          <a:p>
-            <a:pPr marL="0" lvl="0" indent="0">
-              <a:buNone/>
-            </a:pPr>
-            <a:endParaRPr/>
-          </a:p>
-        </p:txBody>
-      </p:sp>
-      <p:sp>
-        <p:nvSpPr>
-          <p:cNvPr id="4" name="Slide Number Placeholder 3"/>
-          <p:cNvSpPr>
-            <a:spLocks noGrp="1"/>
-          </p:cNvSpPr>
-          <p:nvPr>
-            <p:ph type="sldNum" sz="quarter" idx="10"/>
-          </p:nvPr>
-        </p:nvSpPr>
-        <p:spPr/>
-        <p:txBody>
-          <a:bodyPr/>
-          <a:lstStyle/>
-          <a:p>
-            <a:fld id="{18BDFEC3-8487-43E8-A154-7C12CBC1FFF2}" type="slidenum">
-              <a:rPr lang="en-US"/>
-              <a:t>4</a:t>
-            </a:fld>
-            <a:endParaRPr lang="en-US"/>
-          </a:p>
-        </p:txBody>
-      </p:sp>
-    </p:spTree>
-  </p:cSld>
-  <p:clrMapOvr>
-    <a:masterClrMapping/>
-  </p:clrMapOvr>
-</p:notes>
-</file>
-
-<file path=ppt/notesSlides/notesSlide5.xml><?xml version="1.0" encoding="utf-8"?>
-<p:notes xmlns:a="http://schemas.openxmlformats.org/drawingml/2006/main" xmlns:r="http://schemas.openxmlformats.org/officeDocument/2006/relationships" xmlns:p="http://schemas.openxmlformats.org/presentationml/2006/main">
-  <p:cSld>
-    <p:spTree>
-      <p:nvGrpSpPr>
-        <p:cNvPr id="1" name=""/>
-        <p:cNvGrpSpPr/>
-        <p:nvPr/>
-      </p:nvGrpSpPr>
-      <p:grpSpPr>
-        <a:xfrm>
-          <a:off x="0" y="0"/>
-          <a:ext cx="0" cy="0"/>
-          <a:chOff x="0" y="0"/>
-          <a:chExt cx="0" cy="0"/>
-        </a:xfrm>
-      </p:grpSpPr>
-      <p:sp>
-        <p:nvSpPr>
-          <p:cNvPr id="2" name="Slide Image Placeholder 1"/>
-          <p:cNvSpPr>
-            <a:spLocks noGrp="1" noRot="1" noChangeAspect="1"/>
-          </p:cNvSpPr>
-          <p:nvPr>
-            <p:ph type="sldImg"/>
-          </p:nvPr>
-        </p:nvSpPr>
-        <p:spPr/>
-      </p:sp>
-      <p:sp>
-        <p:nvSpPr>
-          <p:cNvPr id="3" name="Notes Placeholder 2"/>
-          <p:cNvSpPr>
-            <a:spLocks noGrp="1"/>
-          </p:cNvSpPr>
-          <p:nvPr>
-            <p:ph type="body" idx="1"/>
-          </p:nvPr>
-        </p:nvSpPr>
-        <p:spPr/>
-        <p:txBody>
-          <a:bodyPr/>
-          <a:lstStyle/>
-          <a:p>
-            <a:endParaRPr lang="de-DE"/>
-          </a:p>
-        </p:txBody>
-      </p:sp>
-      <p:sp>
-        <p:nvSpPr>
-          <p:cNvPr id="4" name="Slide Number Placeholder 3"/>
-          <p:cNvSpPr>
-            <a:spLocks noGrp="1"/>
-          </p:cNvSpPr>
-          <p:nvPr>
-            <p:ph type="sldNum" sz="quarter" idx="5"/>
-          </p:nvPr>
-        </p:nvSpPr>
-        <p:spPr/>
-        <p:txBody>
-          <a:bodyPr/>
-          <a:lstStyle/>
-          <a:p>
-            <a:fld id="{18BDFEC3-8487-43E8-A154-7C12CBC1FFF2}" type="slidenum">
-              <a:rPr lang="en-US" smtClean="0"/>
-              <a:t>5</a:t>
-            </a:fld>
-            <a:endParaRPr lang="en-US"/>
-          </a:p>
-        </p:txBody>
-      </p:sp>
-    </p:spTree>
-    <p:extLst>
-      <p:ext uri="{BB962C8B-B14F-4D97-AF65-F5344CB8AC3E}">
-        <p14:creationId xmlns:p14="http://schemas.microsoft.com/office/powerpoint/2010/main" val="446168957"/>
-      </p:ext>
-    </p:extLst>
-  </p:cSld>
-  <p:clrMapOvr>
-    <a:masterClrMapping/>
-  </p:clrMapOvr>
-</p:notes>
-</file>
-
-<file path=ppt/notesSlides/notesSlide6.xml><?xml version="1.0" encoding="utf-8"?>
-<p:notes xmlns:a="http://schemas.openxmlformats.org/drawingml/2006/main" xmlns:r="http://schemas.openxmlformats.org/officeDocument/2006/relationships" xmlns:p="http://schemas.openxmlformats.org/presentationml/2006/main">
-  <p:cSld>
-    <p:spTree>
-      <p:nvGrpSpPr>
-        <p:cNvPr id="1" name=""/>
-        <p:cNvGrpSpPr/>
-        <p:nvPr/>
-      </p:nvGrpSpPr>
-      <p:grpSpPr>
-        <a:xfrm>
-          <a:off x="0" y="0"/>
-          <a:ext cx="0" cy="0"/>
-          <a:chOff x="0" y="0"/>
-          <a:chExt cx="0" cy="0"/>
-        </a:xfrm>
-      </p:grpSpPr>
-      <p:sp>
-        <p:nvSpPr>
-          <p:cNvPr id="2" name="Slide Image Placeholder 1"/>
-          <p:cNvSpPr>
-            <a:spLocks noGrp="1" noRot="1" noChangeAspect="1"/>
-          </p:cNvSpPr>
-          <p:nvPr>
-            <p:ph type="sldImg"/>
-          </p:nvPr>
-        </p:nvSpPr>
-        <p:spPr/>
-      </p:sp>
-      <p:sp>
-        <p:nvSpPr>
-          <p:cNvPr id="3" name="Notes Placeholder 2"/>
-          <p:cNvSpPr>
-            <a:spLocks noGrp="1"/>
-          </p:cNvSpPr>
-          <p:nvPr>
-            <p:ph type="body" idx="1"/>
-          </p:nvPr>
-        </p:nvSpPr>
-        <p:spPr/>
-        <p:txBody>
-          <a:bodyPr/>
-          <a:lstStyle/>
-          <a:p>
-            <a:pPr marL="0" lvl="0" indent="0">
-              <a:buNone/>
-            </a:pPr>
-            <a:endParaRPr/>
-          </a:p>
-        </p:txBody>
-      </p:sp>
-      <p:sp>
-        <p:nvSpPr>
-          <p:cNvPr id="4" name="Slide Number Placeholder 3"/>
-          <p:cNvSpPr>
-            <a:spLocks noGrp="1"/>
-          </p:cNvSpPr>
-          <p:nvPr>
-            <p:ph type="sldNum" sz="quarter" idx="10"/>
-          </p:nvPr>
-        </p:nvSpPr>
-        <p:spPr/>
-        <p:txBody>
-          <a:bodyPr/>
-          <a:lstStyle/>
-          <a:p>
-            <a:fld id="{18BDFEC3-8487-43E8-A154-7C12CBC1FFF2}" type="slidenum">
-              <a:rPr lang="en-US"/>
-              <a:t>6</a:t>
-            </a:fld>
-            <a:endParaRPr lang="en-US"/>
-          </a:p>
-        </p:txBody>
-      </p:sp>
-    </p:spTree>
-  </p:cSld>
-  <p:clrMapOvr>
-    <a:masterClrMapping/>
-  </p:clrMapOvr>
-</p:notes>
-</file>
-
-<file path=ppt/notesSlides/notesSlide7.xml><?xml version="1.0" encoding="utf-8"?>
-<p:notes xmlns:a="http://schemas.openxmlformats.org/drawingml/2006/main" xmlns:r="http://schemas.openxmlformats.org/officeDocument/2006/relationships" xmlns:p="http://schemas.openxmlformats.org/presentationml/2006/main">
-  <p:cSld>
-    <p:spTree>
-      <p:nvGrpSpPr>
-        <p:cNvPr id="1" name=""/>
-        <p:cNvGrpSpPr/>
-        <p:nvPr/>
-      </p:nvGrpSpPr>
-      <p:grpSpPr>
-        <a:xfrm>
-          <a:off x="0" y="0"/>
-          <a:ext cx="0" cy="0"/>
-          <a:chOff x="0" y="0"/>
-          <a:chExt cx="0" cy="0"/>
-        </a:xfrm>
-      </p:grpSpPr>
-      <p:sp>
-        <p:nvSpPr>
-          <p:cNvPr id="2" name="Slide Image Placeholder 1"/>
-          <p:cNvSpPr>
-            <a:spLocks noGrp="1" noRot="1" noChangeAspect="1"/>
-          </p:cNvSpPr>
-          <p:nvPr>
-            <p:ph type="sldImg"/>
-          </p:nvPr>
-        </p:nvSpPr>
-        <p:spPr/>
-      </p:sp>
-      <p:sp>
-        <p:nvSpPr>
-          <p:cNvPr id="3" name="Notes Placeholder 2"/>
-          <p:cNvSpPr>
-            <a:spLocks noGrp="1"/>
-          </p:cNvSpPr>
-          <p:nvPr>
-            <p:ph type="body" idx="1"/>
-          </p:nvPr>
-        </p:nvSpPr>
-        <p:spPr/>
-        <p:txBody>
-          <a:bodyPr/>
-          <a:lstStyle/>
-          <a:p>
-            <a:pPr marL="0" lvl="0" indent="0">
-              <a:buNone/>
-            </a:pPr>
-            <a:endParaRPr/>
-          </a:p>
-        </p:txBody>
-      </p:sp>
-      <p:sp>
-        <p:nvSpPr>
-          <p:cNvPr id="4" name="Slide Number Placeholder 3"/>
-          <p:cNvSpPr>
-            <a:spLocks noGrp="1"/>
-          </p:cNvSpPr>
-          <p:nvPr>
-            <p:ph type="sldNum" sz="quarter" idx="10"/>
-          </p:nvPr>
-        </p:nvSpPr>
-        <p:spPr/>
-        <p:txBody>
-          <a:bodyPr/>
-          <a:lstStyle/>
-          <a:p>
-            <a:fld id="{18BDFEC3-8487-43E8-A154-7C12CBC1FFF2}" type="slidenum">
-              <a:rPr lang="en-US"/>
-              <a:t>7</a:t>
-            </a:fld>
-            <a:endParaRPr lang="en-US"/>
-          </a:p>
-        </p:txBody>
-      </p:sp>
-    </p:spTree>
-  </p:cSld>
-  <p:clrMapOvr>
-    <a:masterClrMapping/>
-  </p:clrMapOvr>
-</p:notes>
-</file>
-
-<file path=ppt/notesSlides/notesSlide8.xml><?xml version="1.0" encoding="utf-8"?>
-<p:notes xmlns:a="http://schemas.openxmlformats.org/drawingml/2006/main" xmlns:r="http://schemas.openxmlformats.org/officeDocument/2006/relationships" xmlns:p="http://schemas.openxmlformats.org/presentationml/2006/main">
-  <p:cSld>
-    <p:spTree>
-      <p:nvGrpSpPr>
-        <p:cNvPr id="1" name=""/>
-        <p:cNvGrpSpPr/>
-        <p:nvPr/>
-      </p:nvGrpSpPr>
-      <p:grpSpPr>
-        <a:xfrm>
-          <a:off x="0" y="0"/>
-          <a:ext cx="0" cy="0"/>
-          <a:chOff x="0" y="0"/>
-          <a:chExt cx="0" cy="0"/>
-        </a:xfrm>
-      </p:grpSpPr>
-      <p:sp>
-        <p:nvSpPr>
-          <p:cNvPr id="2" name="Slide Image Placeholder 1"/>
-          <p:cNvSpPr>
-            <a:spLocks noGrp="1" noRot="1" noChangeAspect="1"/>
-          </p:cNvSpPr>
-          <p:nvPr>
-            <p:ph type="sldImg"/>
-          </p:nvPr>
-        </p:nvSpPr>
-        <p:spPr/>
-      </p:sp>
-      <p:sp>
-        <p:nvSpPr>
-          <p:cNvPr id="3" name="Notes Placeholder 2"/>
-          <p:cNvSpPr>
-            <a:spLocks noGrp="1"/>
-          </p:cNvSpPr>
-          <p:nvPr>
-            <p:ph type="body" idx="1"/>
-          </p:nvPr>
-        </p:nvSpPr>
-        <p:spPr/>
-        <p:txBody>
-          <a:bodyPr/>
-          <a:lstStyle/>
-          <a:p>
-            <a:endParaRPr lang="de-DE"/>
-          </a:p>
-        </p:txBody>
-      </p:sp>
-      <p:sp>
-        <p:nvSpPr>
-          <p:cNvPr id="4" name="Slide Number Placeholder 3"/>
-          <p:cNvSpPr>
-            <a:spLocks noGrp="1"/>
-          </p:cNvSpPr>
-          <p:nvPr>
-            <p:ph type="sldNum" sz="quarter" idx="5"/>
-          </p:nvPr>
-        </p:nvSpPr>
-        <p:spPr/>
-        <p:txBody>
-          <a:bodyPr/>
-          <a:lstStyle/>
-          <a:p>
-            <a:fld id="{18BDFEC3-8487-43E8-A154-7C12CBC1FFF2}" type="slidenum">
-              <a:rPr lang="en-US" smtClean="0"/>
-              <a:t>8</a:t>
-            </a:fld>
-            <a:endParaRPr lang="en-US"/>
-          </a:p>
-        </p:txBody>
-      </p:sp>
-    </p:spTree>
-    <p:extLst>
-      <p:ext uri="{BB962C8B-B14F-4D97-AF65-F5344CB8AC3E}">
-        <p14:creationId xmlns:p14="http://schemas.microsoft.com/office/powerpoint/2010/main" val="2926897937"/>
-      </p:ext>
-    </p:extLst>
-  </p:cSld>
-  <p:clrMapOvr>
-    <a:masterClrMapping/>
-  </p:clrMapOvr>
-</p:notes>
-</file>
-
-<file path=ppt/notesSlides/notesSlide9.xml><?xml version="1.0" encoding="utf-8"?>
-<p:notes xmlns:a="http://schemas.openxmlformats.org/drawingml/2006/main" xmlns:r="http://schemas.openxmlformats.org/officeDocument/2006/relationships" xmlns:p="http://schemas.openxmlformats.org/presentationml/2006/main">
-  <p:cSld>
-    <p:spTree>
-      <p:nvGrpSpPr>
-        <p:cNvPr id="1" name=""/>
-        <p:cNvGrpSpPr/>
-        <p:nvPr/>
-      </p:nvGrpSpPr>
-      <p:grpSpPr>
-        <a:xfrm>
-          <a:off x="0" y="0"/>
-          <a:ext cx="0" cy="0"/>
-          <a:chOff x="0" y="0"/>
-          <a:chExt cx="0" cy="0"/>
-        </a:xfrm>
-      </p:grpSpPr>
-      <p:sp>
-        <p:nvSpPr>
-          <p:cNvPr id="2" name="Slide Image Placeholder 1"/>
-          <p:cNvSpPr>
-            <a:spLocks noGrp="1" noRot="1" noChangeAspect="1"/>
-          </p:cNvSpPr>
-          <p:nvPr>
-            <p:ph type="sldImg"/>
-          </p:nvPr>
-        </p:nvSpPr>
-        <p:spPr/>
-      </p:sp>
-      <p:sp>
-        <p:nvSpPr>
-          <p:cNvPr id="3" name="Notes Placeholder 2"/>
-          <p:cNvSpPr>
-            <a:spLocks noGrp="1"/>
-          </p:cNvSpPr>
-          <p:nvPr>
-            <p:ph type="body" idx="1"/>
-          </p:nvPr>
-        </p:nvSpPr>
-        <p:spPr/>
-        <p:txBody>
-          <a:bodyPr/>
-          <a:lstStyle/>
-          <a:p>
-            <a:pPr marL="0" lvl="0" indent="0">
-              <a:buNone/>
-            </a:pPr>
-            <a:endParaRPr/>
-          </a:p>
-        </p:txBody>
-      </p:sp>
-      <p:sp>
-        <p:nvSpPr>
-          <p:cNvPr id="4" name="Slide Number Placeholder 3"/>
-          <p:cNvSpPr>
-            <a:spLocks noGrp="1"/>
-          </p:cNvSpPr>
-          <p:nvPr>
-            <p:ph type="sldNum" sz="quarter" idx="10"/>
-          </p:nvPr>
-        </p:nvSpPr>
-        <p:spPr/>
-        <p:txBody>
-          <a:bodyPr/>
-          <a:lstStyle/>
-          <a:p>
-            <a:fld id="{18BDFEC3-8487-43E8-A154-7C12CBC1FFF2}" type="slidenum">
-              <a:rPr lang="en-US"/>
-              <a:t>9</a:t>
-            </a:fld>
-            <a:endParaRPr lang="en-US"/>
-          </a:p>
-        </p:txBody>
-      </p:sp>
-    </p:spTree>
-  </p:cSld>
-  <p:clrMapOvr>
-    <a:masterClrMapping/>
-  </p:clrMapOvr>
 </p:notes>
 </file>
 
@@ -6380,7 +5876,7 @@
 </file>
 
 <file path=ppt/slideMasters/slideMaster1.xml><?xml version="1.0" encoding="utf-8"?>
-<p:sldMaster xmlns:a="http://schemas.openxmlformats.org/drawingml/2006/main" xmlns:r="http://schemas.openxmlformats.org/officeDocument/2006/relationships" xmlns:p="http://schemas.openxmlformats.org/presentationml/2006/main">
+<p:sldMaster xmlns:a="http://schemas.openxmlformats.org/drawingml/2006/main" xmlns:p="http://schemas.openxmlformats.org/presentationml/2006/main" xmlns:r="http://schemas.openxmlformats.org/officeDocument/2006/relationships">
   <p:cSld>
     <p:bg>
       <p:bgRef idx="1001">
@@ -6421,7 +5917,7 @@
           </a:prstGeom>
         </p:spPr>
         <p:txBody>
-          <a:bodyPr vert="horz" lIns="91440" tIns="45720" rIns="91440" bIns="45720" rtlCol="0" anchor="ctr">
+          <a:bodyPr anchor="ctr" bIns="45720" lIns="91440" rIns="91440" rtlCol="0" tIns="45720" vert="horz">
             <a:normAutofit/>
           </a:bodyPr>
           <a:lstStyle/>
@@ -6440,7 +5936,7 @@
             <a:spLocks noGrp="1"/>
           </p:cNvSpPr>
           <p:nvPr>
-            <p:ph type="body" idx="1"/>
+            <p:ph idx="1" type="body"/>
           </p:nvPr>
         </p:nvSpPr>
         <p:spPr>
@@ -6453,7 +5949,7 @@
           </a:prstGeom>
         </p:spPr>
         <p:txBody>
-          <a:bodyPr vert="horz" lIns="91440" tIns="45720" rIns="91440" bIns="45720" rtlCol="0">
+          <a:bodyPr bIns="45720" lIns="91440" rIns="91440" rtlCol="0" tIns="45720" vert="horz">
             <a:normAutofit/>
           </a:bodyPr>
           <a:lstStyle/>
@@ -6501,7 +5997,7 @@
             <a:spLocks noGrp="1"/>
           </p:cNvSpPr>
           <p:nvPr>
-            <p:ph type="dt" sz="half" idx="2"/>
+            <p:ph idx="2" sz="half" type="dt"/>
           </p:nvPr>
         </p:nvSpPr>
         <p:spPr>
@@ -6514,7 +6010,7 @@
           </a:prstGeom>
         </p:spPr>
         <p:txBody>
-          <a:bodyPr vert="horz" lIns="91440" tIns="45720" rIns="91440" bIns="45720" rtlCol="0" anchor="ctr"/>
+          <a:bodyPr anchor="ctr" bIns="45720" lIns="91440" rIns="91440" rtlCol="0" tIns="45720" vert="horz"/>
           <a:lstStyle>
             <a:lvl1pPr algn="l">
               <a:defRPr sz="900">
@@ -6542,7 +6038,7 @@
             <a:spLocks noGrp="1"/>
           </p:cNvSpPr>
           <p:nvPr>
-            <p:ph type="ftr" sz="quarter" idx="3"/>
+            <p:ph idx="3" sz="quarter" type="ftr"/>
           </p:nvPr>
         </p:nvSpPr>
         <p:spPr>
@@ -6555,7 +6051,7 @@
           </a:prstGeom>
         </p:spPr>
         <p:txBody>
-          <a:bodyPr vert="horz" lIns="91440" tIns="45720" rIns="91440" bIns="45720" rtlCol="0" anchor="ctr"/>
+          <a:bodyPr anchor="ctr" bIns="45720" lIns="91440" rIns="91440" rtlCol="0" tIns="45720" vert="horz"/>
           <a:lstStyle>
             <a:lvl1pPr algn="ctr">
               <a:defRPr sz="900">
@@ -6579,7 +6075,7 @@
             <a:spLocks noGrp="1"/>
           </p:cNvSpPr>
           <p:nvPr>
-            <p:ph type="sldNum" sz="quarter" idx="4"/>
+            <p:ph idx="4" sz="quarter" type="sldNum"/>
           </p:nvPr>
         </p:nvSpPr>
         <p:spPr>
@@ -6592,7 +6088,7 @@
           </a:prstGeom>
         </p:spPr>
         <p:txBody>
-          <a:bodyPr vert="horz" lIns="91440" tIns="45720" rIns="91440" bIns="45720" rtlCol="0" anchor="ctr"/>
+          <a:bodyPr anchor="ctr" bIns="45720" lIns="91440" rIns="91440" rtlCol="0" tIns="45720" vert="horz"/>
           <a:lstStyle>
             <a:lvl1pPr algn="r">
               <a:defRPr sz="900">
@@ -6620,7 +6116,7 @@
       </p:ext>
     </p:extLst>
   </p:cSld>
-  <p:clrMap bg1="lt1" tx1="dk1" bg2="lt2" tx2="dk2" accent1="accent1" accent2="accent2" accent3="accent3" accent4="accent4" accent5="accent5" accent6="accent6" hlink="hlink" folHlink="folHlink"/>
+  <p:clrMap accent1="accent1" accent2="accent2" accent3="accent3" accent4="accent4" accent5="accent5" accent6="accent6" bg1="lt1" bg2="lt2" folHlink="folHlink" hlink="hlink" tx1="dk1" tx2="dk2"/>
   <p:sldLayoutIdLst>
     <p:sldLayoutId id="2147483649" r:id="rId1"/>
     <p:sldLayoutId id="2147483651" r:id="rId2"/>
@@ -6642,12 +6138,12 @@
   </p:sldLayoutIdLst>
   <p:txStyles>
     <p:titleStyle>
-      <a:lvl1pPr algn="ctr" defTabSz="342900" rtl="0" eaLnBrk="1" latinLnBrk="0" hangingPunct="1">
+      <a:lvl1pPr algn="ctr" defTabSz="342900" eaLnBrk="1" hangingPunct="1" latinLnBrk="0" rtl="0">
         <a:spcBef>
           <a:spcPct val="0"/>
         </a:spcBef>
         <a:buNone/>
-        <a:defRPr sz="3300" kern="1200">
+        <a:defRPr kern="1200" sz="3300">
           <a:solidFill>
             <a:schemeClr val="tx1"/>
           </a:solidFill>
@@ -6658,13 +6154,13 @@
       </a:lvl1pPr>
     </p:titleStyle>
     <p:bodyStyle>
-      <a:lvl1pPr marL="342900" indent="-342900" algn="l" defTabSz="342900" rtl="0" eaLnBrk="1" latinLnBrk="0" hangingPunct="1">
+      <a:lvl1pPr algn="l" defTabSz="342900" eaLnBrk="1" hangingPunct="1" indent="-342900" latinLnBrk="0" marL="342900" rtl="0">
         <a:spcBef>
           <a:spcPct val="20000"/>
         </a:spcBef>
         <a:buFont typeface="Arial"/>
         <a:buChar char="•"/>
-        <a:defRPr sz="2400" kern="1200">
+        <a:defRPr kern="1200" sz="2400">
           <a:solidFill>
             <a:schemeClr val="tx1"/>
           </a:solidFill>
@@ -6673,13 +6169,13 @@
           <a:cs typeface="+mn-cs"/>
         </a:defRPr>
       </a:lvl1pPr>
-      <a:lvl2pPr marL="685800" indent="-342900" algn="l" defTabSz="342900" rtl="0" eaLnBrk="1" latinLnBrk="0" hangingPunct="1">
+      <a:lvl2pPr algn="l" defTabSz="342900" eaLnBrk="1" hangingPunct="1" indent="-342900" latinLnBrk="0" marL="685800" rtl="0">
         <a:spcBef>
           <a:spcPct val="20000"/>
         </a:spcBef>
         <a:buFont typeface="Arial"/>
         <a:buChar char="–"/>
-        <a:defRPr sz="2100" kern="1200">
+        <a:defRPr kern="1200" sz="2100">
           <a:solidFill>
             <a:schemeClr val="tx1"/>
           </a:solidFill>
@@ -6688,13 +6184,13 @@
           <a:cs typeface="+mn-cs"/>
         </a:defRPr>
       </a:lvl2pPr>
-      <a:lvl3pPr marL="1028700" indent="-342900" algn="l" defTabSz="342900" rtl="0" eaLnBrk="1" latinLnBrk="0" hangingPunct="1">
+      <a:lvl3pPr algn="l" defTabSz="342900" eaLnBrk="1" hangingPunct="1" indent="-342900" latinLnBrk="0" marL="1028700" rtl="0">
         <a:spcBef>
           <a:spcPct val="20000"/>
         </a:spcBef>
         <a:buFont typeface="Arial"/>
         <a:buChar char="•"/>
-        <a:defRPr sz="1800" kern="1200">
+        <a:defRPr kern="1200" sz="1800">
           <a:solidFill>
             <a:schemeClr val="tx1"/>
           </a:solidFill>
@@ -6703,13 +6199,13 @@
           <a:cs typeface="+mn-cs"/>
         </a:defRPr>
       </a:lvl3pPr>
-      <a:lvl4pPr marL="1371600" indent="-342900" algn="l" defTabSz="342900" rtl="0" eaLnBrk="1" latinLnBrk="0" hangingPunct="1">
+      <a:lvl4pPr algn="l" defTabSz="342900" eaLnBrk="1" hangingPunct="1" indent="-342900" latinLnBrk="0" marL="1371600" rtl="0">
         <a:spcBef>
           <a:spcPct val="20000"/>
         </a:spcBef>
         <a:buFont typeface="Arial"/>
         <a:buChar char="–"/>
-        <a:defRPr sz="1500" kern="1200">
+        <a:defRPr kern="1200" sz="1500">
           <a:solidFill>
             <a:schemeClr val="tx1"/>
           </a:solidFill>
@@ -6718,13 +6214,13 @@
           <a:cs typeface="+mn-cs"/>
         </a:defRPr>
       </a:lvl4pPr>
-      <a:lvl5pPr marL="1714500" indent="-342900" algn="l" defTabSz="342900" rtl="0" eaLnBrk="1" latinLnBrk="0" hangingPunct="1">
+      <a:lvl5pPr algn="l" defTabSz="342900" eaLnBrk="1" hangingPunct="1" indent="-342900" latinLnBrk="0" marL="1714500" rtl="0">
         <a:spcBef>
           <a:spcPct val="20000"/>
         </a:spcBef>
         <a:buFont typeface="Arial"/>
         <a:buChar char="»"/>
-        <a:defRPr sz="1500" kern="1200">
+        <a:defRPr kern="1200" sz="1500">
           <a:solidFill>
             <a:schemeClr val="tx1"/>
           </a:solidFill>
@@ -6733,13 +6229,13 @@
           <a:cs typeface="+mn-cs"/>
         </a:defRPr>
       </a:lvl5pPr>
-      <a:lvl6pPr marL="2057400" indent="-342900" algn="l" defTabSz="342900" rtl="0" eaLnBrk="1" latinLnBrk="0" hangingPunct="1">
+      <a:lvl6pPr algn="l" defTabSz="342900" eaLnBrk="1" hangingPunct="1" indent="-342900" latinLnBrk="0" marL="2057400" rtl="0">
         <a:spcBef>
           <a:spcPct val="20000"/>
         </a:spcBef>
         <a:buFont typeface="Arial"/>
         <a:buChar char="•"/>
-        <a:defRPr sz="1500" kern="1200">
+        <a:defRPr kern="1200" sz="1500">
           <a:solidFill>
             <a:schemeClr val="tx1"/>
           </a:solidFill>
@@ -6748,13 +6244,13 @@
           <a:cs typeface="+mn-cs"/>
         </a:defRPr>
       </a:lvl6pPr>
-      <a:lvl7pPr marL="2400300" indent="-342900" algn="l" defTabSz="342900" rtl="0" eaLnBrk="1" latinLnBrk="0" hangingPunct="1">
+      <a:lvl7pPr algn="l" defTabSz="342900" eaLnBrk="1" hangingPunct="1" indent="-342900" latinLnBrk="0" marL="2400300" rtl="0">
         <a:spcBef>
           <a:spcPct val="20000"/>
         </a:spcBef>
         <a:buFont typeface="Arial"/>
         <a:buChar char="•"/>
-        <a:defRPr sz="1500" kern="1200">
+        <a:defRPr kern="1200" sz="1500">
           <a:solidFill>
             <a:schemeClr val="tx1"/>
           </a:solidFill>
@@ -6763,13 +6259,13 @@
           <a:cs typeface="+mn-cs"/>
         </a:defRPr>
       </a:lvl7pPr>
-      <a:lvl8pPr marL="2743200" indent="-342900" algn="l" defTabSz="342900" rtl="0" eaLnBrk="1" latinLnBrk="0" hangingPunct="1">
+      <a:lvl8pPr algn="l" defTabSz="342900" eaLnBrk="1" hangingPunct="1" indent="-342900" latinLnBrk="0" marL="2743200" rtl="0">
         <a:spcBef>
           <a:spcPct val="20000"/>
         </a:spcBef>
         <a:buFont typeface="Arial"/>
         <a:buChar char="•"/>
-        <a:defRPr sz="1500" kern="1200">
+        <a:defRPr kern="1200" sz="1500">
           <a:solidFill>
             <a:schemeClr val="tx1"/>
           </a:solidFill>
@@ -6778,13 +6274,13 @@
           <a:cs typeface="+mn-cs"/>
         </a:defRPr>
       </a:lvl8pPr>
-      <a:lvl9pPr marL="3086100" indent="-342900" algn="l" defTabSz="342900" rtl="0" eaLnBrk="1" latinLnBrk="0" hangingPunct="1">
+      <a:lvl9pPr algn="l" defTabSz="342900" eaLnBrk="1" hangingPunct="1" indent="-342900" latinLnBrk="0" marL="3086100" rtl="0">
         <a:spcBef>
           <a:spcPct val="20000"/>
         </a:spcBef>
         <a:buFont typeface="Arial"/>
         <a:buChar char="•"/>
-        <a:defRPr sz="1500" kern="1200">
+        <a:defRPr kern="1200" sz="1500">
           <a:solidFill>
             <a:schemeClr val="tx1"/>
           </a:solidFill>
@@ -6798,8 +6294,8 @@
       <a:defPPr>
         <a:defRPr lang="en-US"/>
       </a:defPPr>
-      <a:lvl1pPr marL="0" algn="l" defTabSz="342900" rtl="0" eaLnBrk="1" latinLnBrk="0" hangingPunct="1">
-        <a:defRPr sz="1350" kern="1200">
+      <a:lvl1pPr algn="l" defTabSz="342900" eaLnBrk="1" hangingPunct="1" latinLnBrk="0" marL="0" rtl="0">
+        <a:defRPr kern="1200" sz="1350">
           <a:solidFill>
             <a:schemeClr val="tx1"/>
           </a:solidFill>
@@ -6808,8 +6304,8 @@
           <a:cs typeface="+mn-cs"/>
         </a:defRPr>
       </a:lvl1pPr>
-      <a:lvl2pPr marL="342900" algn="l" defTabSz="342900" rtl="0" eaLnBrk="1" latinLnBrk="0" hangingPunct="1">
-        <a:defRPr sz="1350" kern="1200">
+      <a:lvl2pPr algn="l" defTabSz="342900" eaLnBrk="1" hangingPunct="1" latinLnBrk="0" marL="342900" rtl="0">
+        <a:defRPr kern="1200" sz="1350">
           <a:solidFill>
             <a:schemeClr val="tx1"/>
           </a:solidFill>
@@ -6818,8 +6314,8 @@
           <a:cs typeface="+mn-cs"/>
         </a:defRPr>
       </a:lvl2pPr>
-      <a:lvl3pPr marL="685800" algn="l" defTabSz="342900" rtl="0" eaLnBrk="1" latinLnBrk="0" hangingPunct="1">
-        <a:defRPr sz="1350" kern="1200">
+      <a:lvl3pPr algn="l" defTabSz="342900" eaLnBrk="1" hangingPunct="1" latinLnBrk="0" marL="685800" rtl="0">
+        <a:defRPr kern="1200" sz="1350">
           <a:solidFill>
             <a:schemeClr val="tx1"/>
           </a:solidFill>
@@ -6828,8 +6324,8 @@
           <a:cs typeface="+mn-cs"/>
         </a:defRPr>
       </a:lvl3pPr>
-      <a:lvl4pPr marL="1028700" algn="l" defTabSz="342900" rtl="0" eaLnBrk="1" latinLnBrk="0" hangingPunct="1">
-        <a:defRPr sz="1350" kern="1200">
+      <a:lvl4pPr algn="l" defTabSz="342900" eaLnBrk="1" hangingPunct="1" latinLnBrk="0" marL="1028700" rtl="0">
+        <a:defRPr kern="1200" sz="1350">
           <a:solidFill>
             <a:schemeClr val="tx1"/>
           </a:solidFill>
@@ -6838,8 +6334,8 @@
           <a:cs typeface="+mn-cs"/>
         </a:defRPr>
       </a:lvl4pPr>
-      <a:lvl5pPr marL="1371600" algn="l" defTabSz="342900" rtl="0" eaLnBrk="1" latinLnBrk="0" hangingPunct="1">
-        <a:defRPr sz="1350" kern="1200">
+      <a:lvl5pPr algn="l" defTabSz="342900" eaLnBrk="1" hangingPunct="1" latinLnBrk="0" marL="1371600" rtl="0">
+        <a:defRPr kern="1200" sz="1350">
           <a:solidFill>
             <a:schemeClr val="tx1"/>
           </a:solidFill>
@@ -6848,8 +6344,8 @@
           <a:cs typeface="+mn-cs"/>
         </a:defRPr>
       </a:lvl5pPr>
-      <a:lvl6pPr marL="1714500" algn="l" defTabSz="342900" rtl="0" eaLnBrk="1" latinLnBrk="0" hangingPunct="1">
-        <a:defRPr sz="1350" kern="1200">
+      <a:lvl6pPr algn="l" defTabSz="342900" eaLnBrk="1" hangingPunct="1" latinLnBrk="0" marL="1714500" rtl="0">
+        <a:defRPr kern="1200" sz="1350">
           <a:solidFill>
             <a:schemeClr val="tx1"/>
           </a:solidFill>
@@ -6858,8 +6354,8 @@
           <a:cs typeface="+mn-cs"/>
         </a:defRPr>
       </a:lvl6pPr>
-      <a:lvl7pPr marL="2057400" algn="l" defTabSz="342900" rtl="0" eaLnBrk="1" latinLnBrk="0" hangingPunct="1">
-        <a:defRPr sz="1350" kern="1200">
+      <a:lvl7pPr algn="l" defTabSz="342900" eaLnBrk="1" hangingPunct="1" latinLnBrk="0" marL="2057400" rtl="0">
+        <a:defRPr kern="1200" sz="1350">
           <a:solidFill>
             <a:schemeClr val="tx1"/>
           </a:solidFill>
@@ -6868,8 +6364,8 @@
           <a:cs typeface="+mn-cs"/>
         </a:defRPr>
       </a:lvl7pPr>
-      <a:lvl8pPr marL="2400300" algn="l" defTabSz="342900" rtl="0" eaLnBrk="1" latinLnBrk="0" hangingPunct="1">
-        <a:defRPr sz="1350" kern="1200">
+      <a:lvl8pPr algn="l" defTabSz="342900" eaLnBrk="1" hangingPunct="1" latinLnBrk="0" marL="2400300" rtl="0">
+        <a:defRPr kern="1200" sz="1350">
           <a:solidFill>
             <a:schemeClr val="tx1"/>
           </a:solidFill>
@@ -6878,8 +6374,8 @@
           <a:cs typeface="+mn-cs"/>
         </a:defRPr>
       </a:lvl8pPr>
-      <a:lvl9pPr marL="2743200" algn="l" defTabSz="342900" rtl="0" eaLnBrk="1" latinLnBrk="0" hangingPunct="1">
-        <a:defRPr sz="1350" kern="1200">
+      <a:lvl9pPr algn="l" defTabSz="342900" eaLnBrk="1" hangingPunct="1" latinLnBrk="0" marL="2743200" rtl="0">
+        <a:defRPr kern="1200" sz="1350">
           <a:solidFill>
             <a:schemeClr val="tx1"/>
           </a:solidFill>
@@ -6930,10 +6426,11 @@
           <a:bodyPr/>
           <a:lstStyle/>
           <a:p>
-            <a:pPr marL="0" lvl="0" indent="0">
+            <a:pPr lvl="0" indent="0" marL="0">
               <a:buNone/>
             </a:pPr>
             <a:r>
+              <a:rPr/>
               <a:t>Quarto PPTX Layouts: Extension Example</a:t>
             </a:r>
           </a:p>
@@ -6946,7 +6443,7 @@
             <a:spLocks noGrp="1"/>
           </p:cNvSpPr>
           <p:nvPr>
-            <p:ph type="subTitle" idx="1"/>
+            <p:ph idx="1" type="subTitle"/>
           </p:nvPr>
         </p:nvSpPr>
         <p:spPr>
@@ -6959,15 +6456,17 @@
           <a:bodyPr/>
           <a:lstStyle/>
           <a:p>
-            <a:pPr marL="0" lvl="0" indent="0">
+            <a:pPr lvl="0" indent="0" marL="0">
               <a:buNone/>
             </a:pPr>
             <a:r>
+              <a:rPr/>
               <a:t>Showcasing dynamic layout sizing with .smaller and .smallest</a:t>
             </a:r>
             <a:br/>
             <a:br/>
             <a:r>
+              <a:rPr/>
               <a:t>David Rieger</a:t>
             </a:r>
           </a:p>
@@ -6980,28 +6479,26 @@
             <a:spLocks noGrp="1"/>
           </p:cNvSpPr>
           <p:nvPr>
-            <p:ph type="dt" sz="half" idx="10"/>
-          </p:nvPr>
-        </p:nvSpPr>
-        <p:spPr/>
-        <p:txBody>
-          <a:bodyPr/>
-          <a:lstStyle/>
-          <a:p>
-            <a:pPr marL="0" lvl="0" indent="0">
+            <p:ph idx="10" sz="half" type="dt"/>
+          </p:nvPr>
+        </p:nvSpPr>
+        <p:spPr/>
+        <p:txBody>
+          <a:bodyPr/>
+          <a:lstStyle/>
+          <a:p>
+            <a:pPr lvl="0" indent="0" marL="0">
               <a:buNone/>
             </a:pPr>
             <a:r>
-              <a:t>2026-06-17</a:t>
+              <a:rPr/>
+              <a:t>2026-06-30</a:t>
             </a:r>
           </a:p>
         </p:txBody>
       </p:sp>
     </p:spTree>
   </p:cSld>
-  <p:clrMapOvr>
-    <a:masterClrMapping/>
-  </p:clrMapOvr>
 </p:sld>
 </file>
 
@@ -7037,10 +6534,11 @@
           <a:bodyPr/>
           <a:lstStyle/>
           <a:p>
-            <a:pPr marL="0" lvl="0" indent="0">
+            <a:pPr lvl="0" indent="0" marL="0">
               <a:buNone/>
             </a:pPr>
             <a:r>
+              <a:rPr/>
               <a:t>3. Two Content Smallest</a:t>
             </a:r>
           </a:p>
@@ -7053,15 +6551,15 @@
             <a:spLocks noGrp="1"/>
           </p:cNvSpPr>
           <p:nvPr>
-            <p:ph sz="half" idx="1"/>
-          </p:nvPr>
-        </p:nvSpPr>
-        <p:spPr/>
-        <p:txBody>
-          <a:bodyPr/>
-          <a:lstStyle/>
-          <a:p>
-            <a:pPr marL="0" lvl="0" indent="0">
+            <p:ph idx="1" sz="half"/>
+          </p:nvPr>
+        </p:nvSpPr>
+        <p:spPr/>
+        <p:txBody>
+          <a:bodyPr/>
+          <a:lstStyle/>
+          <a:p>
+            <a:pPr lvl="0" indent="0" marL="0">
               <a:spcBef>
                 <a:spcPts val="3000"/>
               </a:spcBef>
@@ -7073,10 +6571,11 @@
             </a:r>
           </a:p>
           <a:p>
-            <a:pPr marL="0" lvl="0" indent="0">
+            <a:pPr lvl="0" indent="0" marL="0">
               <a:buNone/>
             </a:pPr>
             <a:r>
+              <a:rPr/>
               <a:t>Smallest text on the left.</a:t>
             </a:r>
           </a:p>
@@ -7089,15 +6588,15 @@
             <a:spLocks noGrp="1"/>
           </p:cNvSpPr>
           <p:nvPr>
-            <p:ph sz="half" idx="2"/>
-          </p:nvPr>
-        </p:nvSpPr>
-        <p:spPr/>
-        <p:txBody>
-          <a:bodyPr/>
-          <a:lstStyle/>
-          <a:p>
-            <a:pPr marL="0" lvl="0" indent="0">
+            <p:ph idx="2" sz="half"/>
+          </p:nvPr>
+        </p:nvSpPr>
+        <p:spPr/>
+        <p:txBody>
+          <a:bodyPr/>
+          <a:lstStyle/>
+          <a:p>
+            <a:pPr lvl="0" indent="0" marL="0">
               <a:spcBef>
                 <a:spcPts val="3000"/>
               </a:spcBef>
@@ -7109,10 +6608,11 @@
             </a:r>
           </a:p>
           <a:p>
-            <a:pPr marL="0" lvl="0" indent="0">
+            <a:pPr lvl="0" indent="0" marL="0">
               <a:buNone/>
             </a:pPr>
             <a:r>
+              <a:rPr/>
               <a:t>Smallest text on the right.</a:t>
             </a:r>
           </a:p>
@@ -7120,9 +6620,6 @@
       </p:sp>
     </p:spTree>
   </p:cSld>
-  <p:clrMapOvr>
-    <a:masterClrMapping/>
-  </p:clrMapOvr>
 </p:sld>
 </file>
 
@@ -7158,10 +6655,11 @@
           <a:bodyPr/>
           <a:lstStyle/>
           <a:p>
-            <a:pPr marL="0" lvl="0" indent="0">
+            <a:pPr lvl="0" indent="0" marL="0">
               <a:buNone/>
             </a:pPr>
             <a:r>
+              <a:rPr/>
               <a:t>4. Comparison (Normal)</a:t>
             </a:r>
           </a:p>
@@ -7174,18 +6672,19 @@
             <a:spLocks noGrp="1"/>
           </p:cNvSpPr>
           <p:nvPr>
-            <p:ph type="body" idx="1"/>
-          </p:nvPr>
-        </p:nvSpPr>
-        <p:spPr/>
-        <p:txBody>
-          <a:bodyPr/>
-          <a:lstStyle/>
-          <a:p>
-            <a:pPr marL="0" lvl="0" indent="0">
+            <p:ph idx="1" type="body"/>
+          </p:nvPr>
+        </p:nvSpPr>
+        <p:spPr/>
+        <p:txBody>
+          <a:bodyPr/>
+          <a:lstStyle/>
+          <a:p>
+            <a:pPr lvl="0" indent="0" marL="0">
               <a:buNone/>
             </a:pPr>
             <a:r>
+              <a:rPr/>
               <a:t>Normal text left.</a:t>
             </a:r>
           </a:p>
@@ -7193,7 +6692,134 @@
       </p:sp>
       <p:pic>
         <p:nvPicPr>
-          <p:cNvPr id="4" name="Picture 1" descr="test_image.png"/>
+          <p:cNvPr descr="test_image.png" id="0" name="Picture 1"/>
+          <p:cNvPicPr>
+            <a:picLocks noGrp="1" noChangeAspect="1"/>
+          </p:cNvPicPr>
+          <p:nvPr/>
+        </p:nvPicPr>
+        <p:blipFill>
+          <a:blip r:embed="rId2"/>
+          <a:stretch>
+            <a:fillRect/>
+          </a:stretch>
+        </p:blipFill>
+        <p:spPr bwMode="auto">
+          <a:xfrm>
+            <a:off x="990600" y="1625600"/>
+            <a:ext cx="2959100" cy="2959100"/>
+          </a:xfrm>
+          <a:prstGeom prst="rect">
+            <a:avLst/>
+          </a:prstGeom>
+          <a:noFill/>
+          <a:ln w="9525">
+            <a:noFill/>
+            <a:headEnd/>
+            <a:tailEnd/>
+          </a:ln>
+        </p:spPr>
+      </p:pic>
+      <p:sp>
+        <p:nvSpPr>
+          <p:cNvPr id="5" name="Text Placeholder 4"/>
+          <p:cNvSpPr>
+            <a:spLocks noGrp="1"/>
+          </p:cNvSpPr>
+          <p:nvPr>
+            <p:ph idx="3" sz="quarter" type="body"/>
+          </p:nvPr>
+        </p:nvSpPr>
+        <p:spPr/>
+        <p:txBody>
+          <a:bodyPr/>
+          <a:lstStyle/>
+          <a:p>
+            <a:pPr lvl="0" indent="0" marL="0">
+              <a:buNone/>
+            </a:pPr>
+            <a:r>
+              <a:rPr/>
+              <a:t>Normal text right.</a:t>
+            </a:r>
+          </a:p>
+        </p:txBody>
+      </p:sp>
+    </p:spTree>
+  </p:cSld>
+</p:sld>
+</file>
+
+<file path=ppt/slides/slide12.xml><?xml version="1.0" encoding="utf-8"?>
+<p:sld xmlns:a="http://schemas.openxmlformats.org/drawingml/2006/main" xmlns:r="http://schemas.openxmlformats.org/officeDocument/2006/relationships" xmlns:p="http://schemas.openxmlformats.org/presentationml/2006/main">
+  <p:cSld>
+    <p:spTree>
+      <p:nvGrpSpPr>
+        <p:cNvPr id="1" name=""/>
+        <p:cNvGrpSpPr/>
+        <p:nvPr/>
+      </p:nvGrpSpPr>
+      <p:grpSpPr>
+        <a:xfrm>
+          <a:off x="0" y="0"/>
+          <a:ext cx="0" cy="0"/>
+          <a:chOff x="0" y="0"/>
+          <a:chExt cx="0" cy="0"/>
+        </a:xfrm>
+      </p:grpSpPr>
+      <p:sp>
+        <p:nvSpPr>
+          <p:cNvPr id="2" name="Title 1"/>
+          <p:cNvSpPr>
+            <a:spLocks noGrp="1"/>
+          </p:cNvSpPr>
+          <p:nvPr>
+            <p:ph type="title"/>
+          </p:nvPr>
+        </p:nvSpPr>
+        <p:spPr/>
+        <p:txBody>
+          <a:bodyPr/>
+          <a:lstStyle/>
+          <a:p>
+            <a:pPr lvl="0" indent="0" marL="0">
+              <a:buNone/>
+            </a:pPr>
+            <a:r>
+              <a:rPr/>
+              <a:t>4. Comparison Smaller</a:t>
+            </a:r>
+          </a:p>
+        </p:txBody>
+      </p:sp>
+      <p:sp>
+        <p:nvSpPr>
+          <p:cNvPr id="3" name="Text Placeholder 2"/>
+          <p:cNvSpPr>
+            <a:spLocks noGrp="1"/>
+          </p:cNvSpPr>
+          <p:nvPr>
+            <p:ph idx="1" type="body"/>
+          </p:nvPr>
+        </p:nvSpPr>
+        <p:spPr/>
+        <p:txBody>
+          <a:bodyPr/>
+          <a:lstStyle/>
+          <a:p>
+            <a:pPr lvl="0" indent="0" marL="0">
+              <a:buNone/>
+            </a:pPr>
+            <a:r>
+              <a:rPr/>
+              <a:t>Smaller text left.</a:t>
+            </a:r>
+          </a:p>
+        </p:txBody>
+      </p:sp>
+      <p:pic>
+        <p:nvPicPr>
+          <p:cNvPr descr="test_image.png" id="0" name="Picture 1"/>
           <p:cNvPicPr>
             <a:picLocks noGrp="1" noChangeAspect="1"/>
           </p:cNvPicPr>
@@ -7228,32 +6854,30 @@
             <a:spLocks noGrp="1"/>
           </p:cNvSpPr>
           <p:nvPr>
-            <p:ph type="body" sz="quarter" idx="3"/>
-          </p:nvPr>
-        </p:nvSpPr>
-        <p:spPr/>
-        <p:txBody>
-          <a:bodyPr/>
-          <a:lstStyle/>
-          <a:p>
-            <a:pPr marL="0" lvl="0" indent="0">
+            <p:ph idx="3" sz="quarter" type="body"/>
+          </p:nvPr>
+        </p:nvSpPr>
+        <p:spPr/>
+        <p:txBody>
+          <a:bodyPr/>
+          <a:lstStyle/>
+          <a:p>
+            <a:pPr lvl="0" indent="0" marL="0">
               <a:buNone/>
             </a:pPr>
             <a:r>
-              <a:t>Normal text right.</a:t>
+              <a:rPr/>
+              <a:t>Smaller text right.</a:t>
             </a:r>
           </a:p>
         </p:txBody>
       </p:sp>
     </p:spTree>
   </p:cSld>
-  <p:clrMapOvr>
-    <a:masterClrMapping/>
-  </p:clrMapOvr>
 </p:sld>
 </file>
 
-<file path=ppt/slides/slide12.xml><?xml version="1.0" encoding="utf-8"?>
+<file path=ppt/slides/slide13.xml><?xml version="1.0" encoding="utf-8"?>
 <p:sld xmlns:a="http://schemas.openxmlformats.org/drawingml/2006/main" xmlns:r="http://schemas.openxmlformats.org/officeDocument/2006/relationships" xmlns:p="http://schemas.openxmlformats.org/presentationml/2006/main">
   <p:cSld>
     <p:spTree>
@@ -7285,11 +6909,12 @@
           <a:bodyPr/>
           <a:lstStyle/>
           <a:p>
-            <a:pPr marL="0" lvl="0" indent="0">
+            <a:pPr lvl="0" indent="0" marL="0">
               <a:buNone/>
             </a:pPr>
             <a:r>
-              <a:t>4. Comparison Smaller</a:t>
+              <a:rPr/>
+              <a:t>4. Comparison Smallest</a:t>
             </a:r>
           </a:p>
         </p:txBody>
@@ -7301,50 +6926,27 @@
             <a:spLocks noGrp="1"/>
           </p:cNvSpPr>
           <p:nvPr>
-            <p:ph type="body" idx="1"/>
-          </p:nvPr>
-        </p:nvSpPr>
-        <p:spPr/>
-        <p:txBody>
-          <a:bodyPr/>
-          <a:lstStyle/>
-          <a:p>
-            <a:pPr marL="0" lvl="0" indent="0">
+            <p:ph idx="1" type="body"/>
+          </p:nvPr>
+        </p:nvSpPr>
+        <p:spPr/>
+        <p:txBody>
+          <a:bodyPr/>
+          <a:lstStyle/>
+          <a:p>
+            <a:pPr lvl="0" indent="0" marL="0">
               <a:buNone/>
             </a:pPr>
             <a:r>
-              <a:t>Smaller text left.</a:t>
-            </a:r>
-          </a:p>
-        </p:txBody>
-      </p:sp>
-      <p:sp>
-        <p:nvSpPr>
-          <p:cNvPr id="5" name="Text Placeholder 4"/>
-          <p:cNvSpPr>
-            <a:spLocks noGrp="1"/>
-          </p:cNvSpPr>
-          <p:nvPr>
-            <p:ph type="body" sz="quarter" idx="3"/>
-          </p:nvPr>
-        </p:nvSpPr>
-        <p:spPr/>
-        <p:txBody>
-          <a:bodyPr/>
-          <a:lstStyle/>
-          <a:p>
-            <a:pPr marL="0" lvl="0" indent="0">
-              <a:buNone/>
-            </a:pPr>
-            <a:r>
-              <a:t>Smaller text right.</a:t>
+              <a:rPr/>
+              <a:t>Smallest text left.</a:t>
             </a:r>
           </a:p>
         </p:txBody>
       </p:sp>
       <p:pic>
         <p:nvPicPr>
-          <p:cNvPr id="4" name="Picture 1" descr="test_image.png"/>
+          <p:cNvPr descr="test_image.png" id="0" name="Picture 1"/>
           <p:cNvPicPr>
             <a:picLocks noGrp="1" noChangeAspect="1"/>
           </p:cNvPicPr>
@@ -7372,138 +6974,33 @@
           </a:ln>
         </p:spPr>
       </p:pic>
+      <p:sp>
+        <p:nvSpPr>
+          <p:cNvPr id="5" name="Text Placeholder 4"/>
+          <p:cNvSpPr>
+            <a:spLocks noGrp="1"/>
+          </p:cNvSpPr>
+          <p:nvPr>
+            <p:ph idx="3" sz="quarter" type="body"/>
+          </p:nvPr>
+        </p:nvSpPr>
+        <p:spPr/>
+        <p:txBody>
+          <a:bodyPr/>
+          <a:lstStyle/>
+          <a:p>
+            <a:pPr lvl="0" indent="0" marL="0">
+              <a:buNone/>
+            </a:pPr>
+            <a:r>
+              <a:rPr/>
+              <a:t>Smallest text right.</a:t>
+            </a:r>
+          </a:p>
+        </p:txBody>
+      </p:sp>
     </p:spTree>
   </p:cSld>
-  <p:clrMapOvr>
-    <a:masterClrMapping/>
-  </p:clrMapOvr>
-</p:sld>
-</file>
-
-<file path=ppt/slides/slide13.xml><?xml version="1.0" encoding="utf-8"?>
-<p:sld xmlns:a="http://schemas.openxmlformats.org/drawingml/2006/main" xmlns:r="http://schemas.openxmlformats.org/officeDocument/2006/relationships" xmlns:p="http://schemas.openxmlformats.org/presentationml/2006/main">
-  <p:cSld>
-    <p:spTree>
-      <p:nvGrpSpPr>
-        <p:cNvPr id="1" name=""/>
-        <p:cNvGrpSpPr/>
-        <p:nvPr/>
-      </p:nvGrpSpPr>
-      <p:grpSpPr>
-        <a:xfrm>
-          <a:off x="0" y="0"/>
-          <a:ext cx="0" cy="0"/>
-          <a:chOff x="0" y="0"/>
-          <a:chExt cx="0" cy="0"/>
-        </a:xfrm>
-      </p:grpSpPr>
-      <p:sp>
-        <p:nvSpPr>
-          <p:cNvPr id="2" name="Title 1"/>
-          <p:cNvSpPr>
-            <a:spLocks noGrp="1"/>
-          </p:cNvSpPr>
-          <p:nvPr>
-            <p:ph type="title"/>
-          </p:nvPr>
-        </p:nvSpPr>
-        <p:spPr/>
-        <p:txBody>
-          <a:bodyPr/>
-          <a:lstStyle/>
-          <a:p>
-            <a:pPr marL="0" lvl="0" indent="0">
-              <a:buNone/>
-            </a:pPr>
-            <a:r>
-              <a:t>4. Comparison Smallest</a:t>
-            </a:r>
-          </a:p>
-        </p:txBody>
-      </p:sp>
-      <p:sp>
-        <p:nvSpPr>
-          <p:cNvPr id="3" name="Text Placeholder 2"/>
-          <p:cNvSpPr>
-            <a:spLocks noGrp="1"/>
-          </p:cNvSpPr>
-          <p:nvPr>
-            <p:ph type="body" idx="1"/>
-          </p:nvPr>
-        </p:nvSpPr>
-        <p:spPr/>
-        <p:txBody>
-          <a:bodyPr/>
-          <a:lstStyle/>
-          <a:p>
-            <a:pPr marL="0" lvl="0" indent="0">
-              <a:buNone/>
-            </a:pPr>
-            <a:r>
-              <a:t>Smallest text left.</a:t>
-            </a:r>
-          </a:p>
-        </p:txBody>
-      </p:sp>
-      <p:sp>
-        <p:nvSpPr>
-          <p:cNvPr id="5" name="Text Placeholder 4"/>
-          <p:cNvSpPr>
-            <a:spLocks noGrp="1"/>
-          </p:cNvSpPr>
-          <p:nvPr>
-            <p:ph type="body" sz="quarter" idx="3"/>
-          </p:nvPr>
-        </p:nvSpPr>
-        <p:spPr/>
-        <p:txBody>
-          <a:bodyPr/>
-          <a:lstStyle/>
-          <a:p>
-            <a:pPr marL="0" lvl="0" indent="0">
-              <a:buNone/>
-            </a:pPr>
-            <a:r>
-              <a:t>Smallest text right.</a:t>
-            </a:r>
-          </a:p>
-        </p:txBody>
-      </p:sp>
-      <p:pic>
-        <p:nvPicPr>
-          <p:cNvPr id="4" name="Picture 1" descr="test_image.png"/>
-          <p:cNvPicPr>
-            <a:picLocks noGrp="1" noChangeAspect="1"/>
-          </p:cNvPicPr>
-          <p:nvPr/>
-        </p:nvPicPr>
-        <p:blipFill>
-          <a:blip r:embed="rId3"/>
-          <a:stretch>
-            <a:fillRect/>
-          </a:stretch>
-        </p:blipFill>
-        <p:spPr bwMode="auto">
-          <a:xfrm>
-            <a:off x="990600" y="1625600"/>
-            <a:ext cx="2959100" cy="2959100"/>
-          </a:xfrm>
-          <a:prstGeom prst="rect">
-            <a:avLst/>
-          </a:prstGeom>
-          <a:noFill/>
-          <a:ln w="9525">
-            <a:noFill/>
-            <a:headEnd/>
-            <a:tailEnd/>
-          </a:ln>
-        </p:spPr>
-      </p:pic>
-    </p:spTree>
-  </p:cSld>
-  <p:clrMapOvr>
-    <a:masterClrMapping/>
-  </p:clrMapOvr>
 </p:sld>
 </file>
 
@@ -7544,10 +7041,11 @@
           <a:bodyPr/>
           <a:lstStyle/>
           <a:p>
-            <a:pPr marL="0" lvl="0" indent="0">
+            <a:pPr lvl="0" indent="0" marL="0">
               <a:buNone/>
             </a:pPr>
             <a:r>
+              <a:rPr/>
               <a:t>5. Content with Caption (Normal)</a:t>
             </a:r>
           </a:p>
@@ -7560,18 +7058,19 @@
             <a:spLocks noGrp="1"/>
           </p:cNvSpPr>
           <p:nvPr>
-            <p:ph type="body" sz="half" idx="2"/>
-          </p:nvPr>
-        </p:nvSpPr>
-        <p:spPr/>
-        <p:txBody>
-          <a:bodyPr/>
-          <a:lstStyle/>
-          <a:p>
-            <a:pPr marL="0" lvl="0" indent="0">
+            <p:ph idx="2" sz="half" type="body"/>
+          </p:nvPr>
+        </p:nvSpPr>
+        <p:spPr/>
+        <p:txBody>
+          <a:bodyPr/>
+          <a:lstStyle/>
+          <a:p>
+            <a:pPr lvl="0" indent="0" marL="0">
               <a:buNone/>
             </a:pPr>
             <a:r>
+              <a:rPr/>
               <a:t>This slide triggers </a:t>
             </a:r>
             <a:r>
@@ -7579,14 +7078,16 @@
               <a:t>Content with Caption</a:t>
             </a:r>
             <a:r>
+              <a:rPr/>
               <a:t> (single column, text + image).</a:t>
             </a:r>
           </a:p>
           <a:p>
-            <a:pPr marL="0" lvl="0" indent="0">
+            <a:pPr lvl="0" indent="0" marL="0">
               <a:buNone/>
             </a:pPr>
             <a:r>
+              <a:rPr/>
               <a:t>Normal caption text.</a:t>
             </a:r>
           </a:p>
@@ -7594,7 +7095,114 @@
       </p:sp>
       <p:pic>
         <p:nvPicPr>
-          <p:cNvPr id="3" name="Picture 1" descr="test_image.png"/>
+          <p:cNvPr descr="test_image.png" id="0" name="Picture 1"/>
+          <p:cNvPicPr>
+            <a:picLocks noGrp="1" noChangeAspect="1"/>
+          </p:cNvPicPr>
+          <p:nvPr/>
+        </p:nvPicPr>
+        <p:blipFill>
+          <a:blip r:embed="rId2"/>
+          <a:stretch>
+            <a:fillRect/>
+          </a:stretch>
+        </p:blipFill>
+        <p:spPr bwMode="auto">
+          <a:xfrm>
+            <a:off x="3937000" y="203200"/>
+            <a:ext cx="4381500" cy="4381500"/>
+          </a:xfrm>
+          <a:prstGeom prst="rect">
+            <a:avLst/>
+          </a:prstGeom>
+          <a:noFill/>
+          <a:ln w="9525">
+            <a:noFill/>
+            <a:headEnd/>
+            <a:tailEnd/>
+          </a:ln>
+        </p:spPr>
+      </p:pic>
+    </p:spTree>
+  </p:cSld>
+</p:sld>
+</file>
+
+<file path=ppt/slides/slide15.xml><?xml version="1.0" encoding="utf-8"?>
+<p:sld xmlns:a="http://schemas.openxmlformats.org/drawingml/2006/main" xmlns:r="http://schemas.openxmlformats.org/officeDocument/2006/relationships" xmlns:p="http://schemas.openxmlformats.org/presentationml/2006/main">
+  <p:cSld>
+    <p:spTree>
+      <p:nvGrpSpPr>
+        <p:cNvPr id="1" name=""/>
+        <p:cNvGrpSpPr/>
+        <p:nvPr/>
+      </p:nvGrpSpPr>
+      <p:grpSpPr>
+        <a:xfrm>
+          <a:off x="0" y="0"/>
+          <a:ext cx="0" cy="0"/>
+          <a:chOff x="0" y="0"/>
+          <a:chExt cx="0" cy="0"/>
+        </a:xfrm>
+      </p:grpSpPr>
+      <p:sp>
+        <p:nvSpPr>
+          <p:cNvPr id="2" name="Title 1"/>
+          <p:cNvSpPr>
+            <a:spLocks noGrp="1"/>
+          </p:cNvSpPr>
+          <p:nvPr>
+            <p:ph type="title"/>
+          </p:nvPr>
+        </p:nvSpPr>
+        <p:spPr>
+          <a:xfrm>
+            <a:off x="457201" y="204787"/>
+            <a:ext cx="3008313" cy="871538"/>
+          </a:xfrm>
+        </p:spPr>
+        <p:txBody>
+          <a:bodyPr/>
+          <a:lstStyle/>
+          <a:p>
+            <a:pPr lvl="0" indent="0" marL="0">
+              <a:buNone/>
+            </a:pPr>
+            <a:r>
+              <a:rPr/>
+              <a:t>5. Content with Caption Smaller</a:t>
+            </a:r>
+          </a:p>
+        </p:txBody>
+      </p:sp>
+      <p:sp>
+        <p:nvSpPr>
+          <p:cNvPr id="4" name="Text Placeholder 3"/>
+          <p:cNvSpPr>
+            <a:spLocks noGrp="1"/>
+          </p:cNvSpPr>
+          <p:nvPr>
+            <p:ph idx="2" sz="half" type="body"/>
+          </p:nvPr>
+        </p:nvSpPr>
+        <p:spPr/>
+        <p:txBody>
+          <a:bodyPr/>
+          <a:lstStyle/>
+          <a:p>
+            <a:pPr lvl="0" indent="0" marL="0">
+              <a:buNone/>
+            </a:pPr>
+            <a:r>
+              <a:rPr/>
+              <a:t>Smaller caption text.</a:t>
+            </a:r>
+          </a:p>
+        </p:txBody>
+      </p:sp>
+      <p:pic>
+        <p:nvPicPr>
+          <p:cNvPr descr="test_image.png" id="0" name="Picture 1"/>
           <p:cNvPicPr>
             <a:picLocks noGrp="1" noChangeAspect="1"/>
           </p:cNvPicPr>
@@ -7624,13 +7232,10 @@
       </p:pic>
     </p:spTree>
   </p:cSld>
-  <p:clrMapOvr>
-    <a:masterClrMapping/>
-  </p:clrMapOvr>
 </p:sld>
 </file>
 
-<file path=ppt/slides/slide15.xml><?xml version="1.0" encoding="utf-8"?>
+<file path=ppt/slides/slide16.xml><?xml version="1.0" encoding="utf-8"?>
 <p:sld xmlns:a="http://schemas.openxmlformats.org/drawingml/2006/main" xmlns:r="http://schemas.openxmlformats.org/officeDocument/2006/relationships" xmlns:p="http://schemas.openxmlformats.org/presentationml/2006/main">
   <p:cSld>
     <p:spTree>
@@ -7657,16 +7262,22 @@
             <p:ph type="title"/>
           </p:nvPr>
         </p:nvSpPr>
-        <p:spPr/>
-        <p:txBody>
-          <a:bodyPr/>
-          <a:lstStyle/>
-          <a:p>
-            <a:pPr marL="0" lvl="0" indent="0">
+        <p:spPr>
+          <a:xfrm>
+            <a:off x="457201" y="204787"/>
+            <a:ext cx="3008313" cy="871538"/>
+          </a:xfrm>
+        </p:spPr>
+        <p:txBody>
+          <a:bodyPr/>
+          <a:lstStyle/>
+          <a:p>
+            <a:pPr lvl="0" indent="0" marL="0">
               <a:buNone/>
             </a:pPr>
             <a:r>
-              <a:t>5. Content with Caption Smaller</a:t>
+              <a:rPr/>
+              <a:t>5. Content with Caption Smallest</a:t>
             </a:r>
           </a:p>
         </p:txBody>
@@ -7678,26 +7289,27 @@
             <a:spLocks noGrp="1"/>
           </p:cNvSpPr>
           <p:nvPr>
-            <p:ph type="body" sz="half" idx="2"/>
-          </p:nvPr>
-        </p:nvSpPr>
-        <p:spPr/>
-        <p:txBody>
-          <a:bodyPr/>
-          <a:lstStyle/>
-          <a:p>
-            <a:pPr marL="0" lvl="0" indent="0">
+            <p:ph idx="2" sz="half" type="body"/>
+          </p:nvPr>
+        </p:nvSpPr>
+        <p:spPr/>
+        <p:txBody>
+          <a:bodyPr/>
+          <a:lstStyle/>
+          <a:p>
+            <a:pPr lvl="0" indent="0" marL="0">
               <a:buNone/>
             </a:pPr>
             <a:r>
-              <a:t>Smaller caption text.</a:t>
+              <a:rPr/>
+              <a:t>Smallest caption text.</a:t>
             </a:r>
           </a:p>
         </p:txBody>
       </p:sp>
       <p:pic>
         <p:nvPicPr>
-          <p:cNvPr id="3" name="Picture 1" descr="test_image.png"/>
+          <p:cNvPr descr="test_image.png" id="0" name="Picture 1"/>
           <p:cNvPicPr>
             <a:picLocks noGrp="1" noChangeAspect="1"/>
           </p:cNvPicPr>
@@ -7727,112 +7339,6 @@
       </p:pic>
     </p:spTree>
   </p:cSld>
-  <p:clrMapOvr>
-    <a:masterClrMapping/>
-  </p:clrMapOvr>
-</p:sld>
-</file>
-
-<file path=ppt/slides/slide16.xml><?xml version="1.0" encoding="utf-8"?>
-<p:sld xmlns:a="http://schemas.openxmlformats.org/drawingml/2006/main" xmlns:r="http://schemas.openxmlformats.org/officeDocument/2006/relationships" xmlns:p="http://schemas.openxmlformats.org/presentationml/2006/main">
-  <p:cSld>
-    <p:spTree>
-      <p:nvGrpSpPr>
-        <p:cNvPr id="1" name=""/>
-        <p:cNvGrpSpPr/>
-        <p:nvPr/>
-      </p:nvGrpSpPr>
-      <p:grpSpPr>
-        <a:xfrm>
-          <a:off x="0" y="0"/>
-          <a:ext cx="0" cy="0"/>
-          <a:chOff x="0" y="0"/>
-          <a:chExt cx="0" cy="0"/>
-        </a:xfrm>
-      </p:grpSpPr>
-      <p:sp>
-        <p:nvSpPr>
-          <p:cNvPr id="2" name="Title 1"/>
-          <p:cNvSpPr>
-            <a:spLocks noGrp="1"/>
-          </p:cNvSpPr>
-          <p:nvPr>
-            <p:ph type="title"/>
-          </p:nvPr>
-        </p:nvSpPr>
-        <p:spPr/>
-        <p:txBody>
-          <a:bodyPr/>
-          <a:lstStyle/>
-          <a:p>
-            <a:pPr marL="0" lvl="0" indent="0">
-              <a:buNone/>
-            </a:pPr>
-            <a:r>
-              <a:t>5. Content with Caption Smallest</a:t>
-            </a:r>
-          </a:p>
-        </p:txBody>
-      </p:sp>
-      <p:sp>
-        <p:nvSpPr>
-          <p:cNvPr id="4" name="Text Placeholder 3"/>
-          <p:cNvSpPr>
-            <a:spLocks noGrp="1"/>
-          </p:cNvSpPr>
-          <p:nvPr>
-            <p:ph type="body" sz="half" idx="2"/>
-          </p:nvPr>
-        </p:nvSpPr>
-        <p:spPr/>
-        <p:txBody>
-          <a:bodyPr/>
-          <a:lstStyle/>
-          <a:p>
-            <a:pPr marL="0" lvl="0" indent="0">
-              <a:buNone/>
-            </a:pPr>
-            <a:r>
-              <a:t>Smallest caption text.</a:t>
-            </a:r>
-          </a:p>
-        </p:txBody>
-      </p:sp>
-      <p:pic>
-        <p:nvPicPr>
-          <p:cNvPr id="3" name="Picture 1" descr="test_image.png"/>
-          <p:cNvPicPr>
-            <a:picLocks noGrp="1" noChangeAspect="1"/>
-          </p:cNvPicPr>
-          <p:nvPr/>
-        </p:nvPicPr>
-        <p:blipFill>
-          <a:blip r:embed="rId3"/>
-          <a:stretch>
-            <a:fillRect/>
-          </a:stretch>
-        </p:blipFill>
-        <p:spPr bwMode="auto">
-          <a:xfrm>
-            <a:off x="3937000" y="203200"/>
-            <a:ext cx="4381500" cy="4381500"/>
-          </a:xfrm>
-          <a:prstGeom prst="rect">
-            <a:avLst/>
-          </a:prstGeom>
-          <a:noFill/>
-          <a:ln w="9525">
-            <a:noFill/>
-            <a:headEnd/>
-            <a:tailEnd/>
-          </a:ln>
-        </p:spPr>
-      </p:pic>
-    </p:spTree>
-  </p:cSld>
-  <p:clrMapOvr>
-    <a:masterClrMapping/>
-  </p:clrMapOvr>
 </p:sld>
 </file>
 
@@ -7873,10 +7379,11 @@
           <a:bodyPr/>
           <a:lstStyle/>
           <a:p>
-            <a:pPr marL="0" lvl="0" indent="0">
+            <a:pPr lvl="0" indent="0" marL="0">
               <a:buNone/>
             </a:pPr>
             <a:r>
+              <a:rPr/>
               <a:t>1. Section Header (Normal)</a:t>
             </a:r>
           </a:p>
@@ -7884,9 +7391,6 @@
       </p:sp>
     </p:spTree>
   </p:cSld>
-  <p:clrMapOvr>
-    <a:masterClrMapping/>
-  </p:clrMapOvr>
 </p:sld>
 </file>
 
@@ -7917,15 +7421,21 @@
             <p:ph type="title"/>
           </p:nvPr>
         </p:nvSpPr>
-        <p:spPr/>
-        <p:txBody>
-          <a:bodyPr/>
-          <a:lstStyle/>
-          <a:p>
-            <a:pPr marL="0" lvl="0" indent="0">
+        <p:spPr>
+          <a:xfrm>
+            <a:off x="722313" y="3305176"/>
+            <a:ext cx="7772400" cy="1021556"/>
+          </a:xfrm>
+        </p:spPr>
+        <p:txBody>
+          <a:bodyPr/>
+          <a:lstStyle/>
+          <a:p>
+            <a:pPr lvl="0" indent="0" marL="0">
               <a:buNone/>
             </a:pPr>
             <a:r>
+              <a:rPr/>
               <a:t>1. Section Header Smaller</a:t>
             </a:r>
           </a:p>
@@ -7933,9 +7443,6 @@
       </p:sp>
     </p:spTree>
   </p:cSld>
-  <p:clrMapOvr>
-    <a:masterClrMapping/>
-  </p:clrMapOvr>
 </p:sld>
 </file>
 
@@ -7966,15 +7473,21 @@
             <p:ph type="title"/>
           </p:nvPr>
         </p:nvSpPr>
-        <p:spPr/>
-        <p:txBody>
-          <a:bodyPr/>
-          <a:lstStyle/>
-          <a:p>
-            <a:pPr marL="0" lvl="0" indent="0">
+        <p:spPr>
+          <a:xfrm>
+            <a:off x="722313" y="3305176"/>
+            <a:ext cx="7772400" cy="1021556"/>
+          </a:xfrm>
+        </p:spPr>
+        <p:txBody>
+          <a:bodyPr/>
+          <a:lstStyle/>
+          <a:p>
+            <a:pPr lvl="0" indent="0" marL="0">
               <a:buNone/>
             </a:pPr>
             <a:r>
+              <a:rPr/>
               <a:t>1. Section Header Smallest</a:t>
             </a:r>
           </a:p>
@@ -7982,9 +7495,6 @@
       </p:sp>
     </p:spTree>
   </p:cSld>
-  <p:clrMapOvr>
-    <a:masterClrMapping/>
-  </p:clrMapOvr>
 </p:sld>
 </file>
 
@@ -8020,10 +7530,11 @@
           <a:bodyPr/>
           <a:lstStyle/>
           <a:p>
-            <a:pPr marL="0" lvl="0" indent="0">
+            <a:pPr lvl="0" indent="0" marL="0">
               <a:buNone/>
             </a:pPr>
             <a:r>
+              <a:rPr/>
               <a:t>2. Title and Content (Normal)</a:t>
             </a:r>
           </a:p>
@@ -8044,10 +7555,11 @@
           <a:bodyPr/>
           <a:lstStyle/>
           <a:p>
-            <a:pPr marL="0" lvl="0" indent="0">
+            <a:pPr lvl="0" indent="0" marL="0">
               <a:buNone/>
             </a:pPr>
             <a:r>
+              <a:rPr/>
               <a:t>This is a standard slide (</a:t>
             </a:r>
             <a:r>
@@ -8057,6 +7569,7 @@
               <a:t>##</a:t>
             </a:r>
             <a:r>
+              <a:rPr/>
               <a:t>), triggering the </a:t>
             </a:r>
             <a:r>
@@ -8064,24 +7577,28 @@
               <a:t>Title and Content</a:t>
             </a:r>
             <a:r>
+              <a:rPr/>
               <a:t> layout. Everything is at normal size.</a:t>
             </a:r>
           </a:p>
           <a:p>
             <a:pPr lvl="0"/>
             <a:r>
+              <a:rPr/>
               <a:t>Point A</a:t>
             </a:r>
           </a:p>
           <a:p>
             <a:pPr lvl="0"/>
             <a:r>
+              <a:rPr/>
               <a:t>Point B</a:t>
             </a:r>
           </a:p>
           <a:p>
             <a:pPr lvl="0"/>
             <a:r>
+              <a:rPr/>
               <a:t>Point C</a:t>
             </a:r>
           </a:p>
@@ -8089,9 +7606,6 @@
       </p:sp>
     </p:spTree>
   </p:cSld>
-  <p:clrMapOvr>
-    <a:masterClrMapping/>
-  </p:clrMapOvr>
 </p:sld>
 </file>
 
@@ -8127,10 +7641,11 @@
           <a:bodyPr/>
           <a:lstStyle/>
           <a:p>
-            <a:pPr marL="0" lvl="0" indent="0">
+            <a:pPr lvl="0" indent="0" marL="0">
               <a:buNone/>
             </a:pPr>
             <a:r>
+              <a:rPr/>
               <a:t>2. Title and Content Smaller</a:t>
             </a:r>
           </a:p>
@@ -8151,10 +7666,11 @@
           <a:bodyPr/>
           <a:lstStyle/>
           <a:p>
-            <a:pPr marL="0" lvl="0" indent="0">
+            <a:pPr lvl="0" indent="0" marL="0">
               <a:buNone/>
             </a:pPr>
             <a:r>
+              <a:rPr/>
               <a:t>This is the </a:t>
             </a:r>
             <a:r>
@@ -8164,24 +7680,28 @@
               <a:t>.smaller</a:t>
             </a:r>
             <a:r>
+              <a:rPr/>
               <a:t> variant.</a:t>
             </a:r>
           </a:p>
           <a:p>
             <a:pPr lvl="0"/>
             <a:r>
+              <a:rPr/>
               <a:t>Point A</a:t>
             </a:r>
           </a:p>
           <a:p>
             <a:pPr lvl="0"/>
             <a:r>
+              <a:rPr/>
               <a:t>Point B</a:t>
             </a:r>
           </a:p>
           <a:p>
             <a:pPr lvl="0"/>
             <a:r>
+              <a:rPr/>
               <a:t>Point C</a:t>
             </a:r>
           </a:p>
@@ -8189,9 +7709,6 @@
       </p:sp>
     </p:spTree>
   </p:cSld>
-  <p:clrMapOvr>
-    <a:masterClrMapping/>
-  </p:clrMapOvr>
 </p:sld>
 </file>
 
@@ -8227,10 +7744,11 @@
           <a:bodyPr/>
           <a:lstStyle/>
           <a:p>
-            <a:pPr marL="0" lvl="0" indent="0">
+            <a:pPr lvl="0" indent="0" marL="0">
               <a:buNone/>
             </a:pPr>
             <a:r>
+              <a:rPr/>
               <a:t>2. Title and Content Smallest</a:t>
             </a:r>
           </a:p>
@@ -8251,10 +7769,11 @@
           <a:bodyPr/>
           <a:lstStyle/>
           <a:p>
-            <a:pPr marL="0" lvl="0" indent="0">
+            <a:pPr lvl="0" indent="0" marL="0">
               <a:buNone/>
             </a:pPr>
             <a:r>
+              <a:rPr/>
               <a:t>This is the </a:t>
             </a:r>
             <a:r>
@@ -8264,24 +7783,28 @@
               <a:t>.smallest</a:t>
             </a:r>
             <a:r>
+              <a:rPr/>
               <a:t> variant.</a:t>
             </a:r>
           </a:p>
           <a:p>
             <a:pPr lvl="0"/>
             <a:r>
+              <a:rPr/>
               <a:t>Point A</a:t>
             </a:r>
           </a:p>
           <a:p>
             <a:pPr lvl="0"/>
             <a:r>
+              <a:rPr/>
               <a:t>Point B</a:t>
             </a:r>
           </a:p>
           <a:p>
             <a:pPr lvl="0"/>
             <a:r>
+              <a:rPr/>
               <a:t>Point C</a:t>
             </a:r>
           </a:p>
@@ -8289,9 +7812,6 @@
       </p:sp>
     </p:spTree>
   </p:cSld>
-  <p:clrMapOvr>
-    <a:masterClrMapping/>
-  </p:clrMapOvr>
 </p:sld>
 </file>
 
@@ -8327,10 +7847,11 @@
           <a:bodyPr/>
           <a:lstStyle/>
           <a:p>
-            <a:pPr marL="0" lvl="0" indent="0">
+            <a:pPr lvl="0" indent="0" marL="0">
               <a:buNone/>
             </a:pPr>
             <a:r>
+              <a:rPr/>
               <a:t>3. Two Content (Normal)</a:t>
             </a:r>
           </a:p>
@@ -8343,15 +7864,15 @@
             <a:spLocks noGrp="1"/>
           </p:cNvSpPr>
           <p:nvPr>
-            <p:ph sz="half" idx="1"/>
-          </p:nvPr>
-        </p:nvSpPr>
-        <p:spPr/>
-        <p:txBody>
-          <a:bodyPr/>
-          <a:lstStyle/>
-          <a:p>
-            <a:pPr marL="0" lvl="0" indent="0">
+            <p:ph idx="1" sz="half"/>
+          </p:nvPr>
+        </p:nvSpPr>
+        <p:spPr/>
+        <p:txBody>
+          <a:bodyPr/>
+          <a:lstStyle/>
+          <a:p>
+            <a:pPr lvl="0" indent="0" marL="0">
               <a:spcBef>
                 <a:spcPts val="3000"/>
               </a:spcBef>
@@ -8363,10 +7884,11 @@
             </a:r>
           </a:p>
           <a:p>
-            <a:pPr marL="0" lvl="0" indent="0">
+            <a:pPr lvl="0" indent="0" marL="0">
               <a:buNone/>
             </a:pPr>
             <a:r>
+              <a:rPr/>
               <a:t>Normal text on the left.</a:t>
             </a:r>
           </a:p>
@@ -8379,15 +7901,15 @@
             <a:spLocks noGrp="1"/>
           </p:cNvSpPr>
           <p:nvPr>
-            <p:ph sz="half" idx="2"/>
-          </p:nvPr>
-        </p:nvSpPr>
-        <p:spPr/>
-        <p:txBody>
-          <a:bodyPr/>
-          <a:lstStyle/>
-          <a:p>
-            <a:pPr marL="0" lvl="0" indent="0">
+            <p:ph idx="2" sz="half"/>
+          </p:nvPr>
+        </p:nvSpPr>
+        <p:spPr/>
+        <p:txBody>
+          <a:bodyPr/>
+          <a:lstStyle/>
+          <a:p>
+            <a:pPr lvl="0" indent="0" marL="0">
               <a:spcBef>
                 <a:spcPts val="3000"/>
               </a:spcBef>
@@ -8399,10 +7921,11 @@
             </a:r>
           </a:p>
           <a:p>
-            <a:pPr marL="0" lvl="0" indent="0">
+            <a:pPr lvl="0" indent="0" marL="0">
               <a:buNone/>
             </a:pPr>
             <a:r>
+              <a:rPr/>
               <a:t>Normal text on the right.</a:t>
             </a:r>
           </a:p>
@@ -8410,9 +7933,6 @@
       </p:sp>
     </p:spTree>
   </p:cSld>
-  <p:clrMapOvr>
-    <a:masterClrMapping/>
-  </p:clrMapOvr>
 </p:sld>
 </file>
 
@@ -8448,10 +7968,11 @@
           <a:bodyPr/>
           <a:lstStyle/>
           <a:p>
-            <a:pPr marL="0" lvl="0" indent="0">
+            <a:pPr lvl="0" indent="0" marL="0">
               <a:buNone/>
             </a:pPr>
             <a:r>
+              <a:rPr/>
               <a:t>3. Two Content Smaller</a:t>
             </a:r>
           </a:p>
@@ -8464,15 +7985,15 @@
             <a:spLocks noGrp="1"/>
           </p:cNvSpPr>
           <p:nvPr>
-            <p:ph sz="half" idx="1"/>
-          </p:nvPr>
-        </p:nvSpPr>
-        <p:spPr/>
-        <p:txBody>
-          <a:bodyPr/>
-          <a:lstStyle/>
-          <a:p>
-            <a:pPr marL="0" lvl="0" indent="0">
+            <p:ph idx="1" sz="half"/>
+          </p:nvPr>
+        </p:nvSpPr>
+        <p:spPr/>
+        <p:txBody>
+          <a:bodyPr/>
+          <a:lstStyle/>
+          <a:p>
+            <a:pPr lvl="0" indent="0" marL="0">
               <a:spcBef>
                 <a:spcPts val="3000"/>
               </a:spcBef>
@@ -8484,10 +8005,11 @@
             </a:r>
           </a:p>
           <a:p>
-            <a:pPr marL="0" lvl="0" indent="0">
+            <a:pPr lvl="0" indent="0" marL="0">
               <a:buNone/>
             </a:pPr>
             <a:r>
+              <a:rPr/>
               <a:t>Smaller text on the left.</a:t>
             </a:r>
           </a:p>
@@ -8500,15 +8022,15 @@
             <a:spLocks noGrp="1"/>
           </p:cNvSpPr>
           <p:nvPr>
-            <p:ph sz="half" idx="2"/>
-          </p:nvPr>
-        </p:nvSpPr>
-        <p:spPr/>
-        <p:txBody>
-          <a:bodyPr/>
-          <a:lstStyle/>
-          <a:p>
-            <a:pPr marL="0" lvl="0" indent="0">
+            <p:ph idx="2" sz="half"/>
+          </p:nvPr>
+        </p:nvSpPr>
+        <p:spPr/>
+        <p:txBody>
+          <a:bodyPr/>
+          <a:lstStyle/>
+          <a:p>
+            <a:pPr lvl="0" indent="0" marL="0">
               <a:spcBef>
                 <a:spcPts val="3000"/>
               </a:spcBef>
@@ -8520,10 +8042,11 @@
             </a:r>
           </a:p>
           <a:p>
-            <a:pPr marL="0" lvl="0" indent="0">
+            <a:pPr lvl="0" indent="0" marL="0">
               <a:buNone/>
             </a:pPr>
             <a:r>
+              <a:rPr/>
               <a:t>Smaller text on the right.</a:t>
             </a:r>
           </a:p>
@@ -8531,9 +8054,6 @@
       </p:sp>
     </p:spTree>
   </p:cSld>
-  <p:clrMapOvr>
-    <a:masterClrMapping/>
-  </p:clrMapOvr>
 </p:sld>
 </file>
 

</xml_diff>